<commit_message>
M10: Sim-Review umgesetzt (sim_review true, Inhalt aktualisiert)
Co-Authored-By: Claude Opus 4.8 <noreply@anthropic.com>
</commit_message>
<xml_diff>
--- a/protected-downloads/praesentation/M10.pptx
+++ b/protected-downloads/praesentation/M10.pptx
@@ -580,7 +580,7 @@
           <a:lstStyle/>
           <a:p>
             <a:r>
-              <a:t>Moderation (HB Sec 3): Konkreten Satz aus dem Berufsalltag nehmen: z.B. Unternehmer sagt: „Wir brauchen eigentlich keine neue Finanzierung." Trainer fragt: Was hören Sie auf welchem Ohr? Häufig: TN hören nur auf dem Sachohr. Dann zeigen: Selbstoffenbarung = „Ich habe Angst vor Abhängigkeit"; Appell = „Zeigen Sie mir einen Mehrwert, der meinen Preis wert ist." Typische Teilnehmerreaktion: „Das ist doch Überinterpretation." → Gegenargument: Im Zweifel besser eine Ebene zu viel prüfen als eine zu wenig. Im Firmenkundengeschäft sind offene Gesprächspunkte teuer.</a:t>
+              <a:t>Moderation (HB Sec 3): Konkreten Satz aus dem Berufsalltag nehmen: z.B. Unternehmer sagt: „Wir brauchen eigentlich keine neue Finanzierung." Trainer fragt: Was hören Sie auf welchem Ohr? Häufig: TN hören nur auf dem Sachohr. Dann zeigen: Selbstoffenbarung = „Ich habe Angst vor Abhängigkeit"; Appell = „Zeigen Sie mir einen Mehrwert, der meinen Preis wert ist." Typische Teilnehmerreaktion: „Das ist doch Überinterpretation." → Gegenargument: Im Zweifel besser eine Ebene zu viel prüfen als eine zu wenig. Im Firmenkundengeschäft sind offene Gesprächspunkte teuer. Antizipierter Senior-Einwand „Das ist Psychologie, nicht Bankberatung": Dieser Einwand kommt vorhersehbar von erfahrenen TN. Konkrete Antwort (sofort einsetzbar, ohne auf die Übungsphase zu warten): „Das Modell soll keine Therapiesitzung einleiten. Es gibt Ihnen eine Antenne für den Moment, in dem der Kunde zögert, das Thema wechselt oder kürzer als gewohnt antwortet. Wann hatten Sie zuletzt ein Gespräch, in dem der Kunde ‚eigentlich läuft alles gut' gesagt hat – und am Ende war das Ergebnis trotzdem mager? Dann waren Sie auf dem falschen Ohr." Danach direkt in die Kurzübung einsteigen. Rückkopplung in der Kurzübung sichern: Die Kurzübung (Trainer spielt Satz, TN sortieren auf vier Ebenen) endet nicht mit dem Einsammeln der Zettel. Mindestens einen skeptischen TN direkt – einladend, nicht defensiv – ansprechen: „Sie haben schnell abgegeben. Was haben Sie auf dem Appell-Ohr gehört?" Die Antwort ist nicht falsch oder richtig; entscheidend ist, ob er überhaupt eine Ebene außer dem Sachinhalt bemerkt hat. Sonst bleibt die Lernlücke skeptischer TN ungeprüft.</a:t>
             </a:r>
           </a:p>
         </p:txBody>
@@ -650,7 +650,7 @@
           <a:lstStyle/>
           <a:p>
             <a:r>
-              <a:t>Moderation (HB Sec 3): Bei der Demo: Trainer bricht nach 8–10 Min ab und fragt TN: „Was hat der Berater gut gemacht?" und „Wo hätte er vertiefen sollen?" – dies erhöht die Lernintensität durch Beobachterrolle. Im Rollenspiel: Unternehmerrolle gibt Instruktionen auf dem Rollenkarten-Rücken, die nur der Unternehmer-Spieler kennt (z. B. „Nachfolge ist ein echtes Problem, aber Sie sprechen nicht darüber, bis Sie direkt gefragt werden"). Dies erzeugt realistische latente Bedarfe.</a:t>
+              <a:t>Moderation (HB Sec 3): Bei der Demo: Trainer bricht nach 8–10 Min ab und fragt TN: „Was hat der Berater gut gemacht?" und „Wo hätte er vertiefen sollen?" – dies erhöht die Lernintensität durch Beobachterrolle. Moment-Aufgriff (höchster Lernwert): Falls ein TN während der Demo aus der Rolle tritt und eine Methode kommentiert (z. B. „Das ist eine gute I-Frage"), sofort aufgreifen statt überhören: „Sie sind gerade rausgegangen – was hat Sie bei dieser Frage überrascht?" Kurz pausieren, TN ausreden lassen, dann weiter im Demo-Gespräch. Dieser Moment ist wertvoller als die nächste SPIN-Frage des Trainers. Rollenspiel-Instruktion – Beobachter sind stille Zeugen: Beobachter beobachten schweigend. Kein Unterbrechen, kein Kommentieren während des Gesprächs. Ausnahme: Stopp-Signal ausschließlich durch den Trainer (Handzeichen). Feedback erst in der 5-minütigen Bogen-Besprechung. Instruktion für die TN-Karte: „Als Beobachter sind Sie der stille Zeuge. Ihr Feedback ist das wertvollste am Ende – nicht dazwischen." Hintergrund: Ein Feedback-Kommentar mitten im Gespräch destabilisiert gerade unsichere Berater in dem Moment, in dem sie eine neue Fragetechnik ausprobieren. Rollenkarten-Vorbereitung: Die Rollenkarte mit den latenten Bedarfen (Sec 4.3) nicht in die TN-Unterlagen drucken. Sie ist ein separates Handout nur für den Unternehmer-Spieler – sonst sieht jeder Berater die latenten Bedarfe vorab und das Überraschungsmoment des Rollenspiels geht verloren. Im Rollenspiel gibt die Unternehmerrolle Instruktionen auf dem Rollenkarten-Rücken, die nur der Unternehmer-Spieler kennt (z. B. „Nachfolge ist ein echtes Problem, aber Sie sprechen nicht darüber, bis Sie direkt gefragt werden"). Dies erzeugt realistische latente Bedarfe. Fokussierter Beobachtungsauftrag Runde 1: In Runde 1 nur drei Dinge beobachten lassen (der volle 10-Kriterien-Bogen überfordert in 10 Minuten): (1) Verhältnis Berater-Redezeit zu Unternehmer-Redezeit, (2) Wann stellt der Berater eine Frage, deren Antwort ihn überrascht?, (3) Wann geht er von P direkt zur Lösung, ohne eine I-Frage zu stellen? Erst in Runde 2 den vollständigen Bogen einsetzen.</a:t>
             </a:r>
           </a:p>
         </p:txBody>
@@ -4992,7 +4992,7 @@
                 </a:solidFill>
                 <a:latin typeface="Arial"/>
               </a:rPr>
-              <a:t>▸  Kundensignale auf den vier Kommunikationsebenen nach Schulz von Thun differenziert erkennen und den Bedeutungsrahmen hinter sachlichen Aussagen entschlüsseln</a:t>
+              <a:t>▸  Kundensignale auf den vier Kommunikationsebenen nach Schulz von Thun differenziert analysieren und den Bedeutungsrahmen hinter sachlichen Aussagen entschlüsseln</a:t>
             </a:r>
           </a:p>
           <a:p>
@@ -5533,7 +5533,7 @@
                 </a:solidFill>
                 <a:latin typeface="Consolas"/>
               </a:rPr>
-              <a:t>80–88'      </a:t>
+              <a:t>80–90'      </a:t>
             </a:r>
             <a:r>
               <a:rPr sz="1500" b="1">
@@ -5570,7 +5570,7 @@
                 </a:solidFill>
                 <a:latin typeface="Consolas"/>
               </a:rPr>
-              <a:t>88–90'      </a:t>
+              <a:t>90–95'      </a:t>
             </a:r>
             <a:r>
               <a:rPr sz="1500" b="1">

</xml_diff>

<commit_message>
M-Track Batch 2: M10 Deck (Web/Workbook)
Co-Authored-By: Claude Fable 5 <noreply@anthropic.com>
</commit_message>
<xml_diff>
--- a/protected-downloads/praesentation/M10.pptx
+++ b/protected-downloads/praesentation/M10.pptx
@@ -14,6 +14,9 @@
     <p:sldId id="262" r:id="rId14"/>
     <p:sldId id="263" r:id="rId15"/>
     <p:sldId id="264" r:id="rId16"/>
+    <p:sldId id="265" r:id="rId17"/>
+    <p:sldId id="266" r:id="rId18"/>
+    <p:sldId id="267" r:id="rId19"/>
   </p:sldIdLst>
   <p:sldSz cx="12188952" cy="6858000" type="screen4x3"/>
   <p:notesSz cx="6858000" cy="9144000"/>
@@ -580,6 +583,11 @@
           <a:lstStyle/>
           <a:p>
             <a:r>
+              <a:t>Einstieg: eine Kundenaussage auf allen vier Ohren durchspielen – „Ihre Konditionen sind aber hoch."</a:t>
+            </a:r>
+          </a:p>
+          <a:p>
+            <a:r>
               <a:t>Moderation (HB Sec 3): Konkreten Satz aus dem Berufsalltag nehmen: z.B. Unternehmer sagt: „Wir brauchen eigentlich keine neue Finanzierung." Trainer fragt: Was hören Sie auf welchem Ohr? Häufig: TN hören nur auf dem Sachohr. Dann zeigen: Selbstoffenbarung = „Ich habe Angst vor Abhängigkeit"; Appell = „Zeigen Sie mir einen Mehrwert, der meinen Preis wert ist." Typische Teilnehmerreaktion: „Das ist doch Überinterpretation." → Gegenargument: Im Zweifel besser eine Ebene zu viel prüfen als eine zu wenig. Im Firmenkundengeschäft sind offene Gesprächspunkte teuer. Antizipierter Senior-Einwand „Das ist Psychologie, nicht Bankberatung": Dieser Einwand kommt vorhersehbar von erfahrenen TN. Konkrete Antwort (sofort einsetzbar, ohne auf die Übungsphase zu warten): „Das Modell soll keine Therapiesitzung einleiten. Es gibt Ihnen eine Antenne für den Moment, in dem der Kunde zögert, das Thema wechselt oder kürzer als gewohnt antwortet. Wann hatten Sie zuletzt ein Gespräch, in dem der Kunde ‚eigentlich läuft alles gut' gesagt hat – und am Ende war das Ergebnis trotzdem mager? Dann waren Sie auf dem falschen Ohr." Danach direkt in die Kurzübung einsteigen. Rückkopplung in der Kurzübung sichern: Die Kurzübung (Trainer spielt Satz, TN sortieren auf vier Ebenen) endet nicht mit dem Einsammeln der Zettel. Mindestens einen skeptischen TN direkt – einladend, nicht defensiv – ansprechen: „Sie haben schnell abgegeben. Was haben Sie auf dem Appell-Ohr gehört?" Die Antwort ist nicht falsch oder richtig; entscheidend ist, ob er überhaupt eine Ebene außer dem Sachinhalt bemerkt hat. Sonst bleibt die Lernlücke skeptischer TN ungeprüft.</a:t>
             </a:r>
           </a:p>
@@ -650,7 +658,12 @@
           <a:lstStyle/>
           <a:p>
             <a:r>
-              <a:t>Moderation (HB Sec 3): Bei der Demo: Trainer bricht nach 8–10 Min ab und fragt TN: „Was hat der Berater gut gemacht?" und „Wo hätte er vertiefen sollen?" – dies erhöht die Lernintensität durch Beobachterrolle. Moment-Aufgriff (höchster Lernwert): Falls ein TN während der Demo aus der Rolle tritt und eine Methode kommentiert (z. B. „Das ist eine gute I-Frage"), sofort aufgreifen statt überhören: „Sie sind gerade rausgegangen – was hat Sie bei dieser Frage überrascht?" Kurz pausieren, TN ausreden lassen, dann weiter im Demo-Gespräch. Dieser Moment ist wertvoller als die nächste SPIN-Frage des Trainers. Rollenspiel-Instruktion – Beobachter sind stille Zeugen: Beobachter beobachten schweigend. Kein Unterbrechen, kein Kommentieren während des Gesprächs. Ausnahme: Stopp-Signal ausschließlich durch den Trainer (Handzeichen). Feedback erst in der 5-minütigen Bogen-Besprechung. Instruktion für die TN-Karte: „Als Beobachter sind Sie der stille Zeuge. Ihr Feedback ist das wertvollste am Ende – nicht dazwischen." Hintergrund: Ein Feedback-Kommentar mitten im Gespräch destabilisiert gerade unsichere Berater in dem Moment, in dem sie eine neue Fragetechnik ausprobieren. Rollenkarten-Vorbereitung: Die Rollenkarte mit den latenten Bedarfen (Sec 4.3) nicht in die TN-Unterlagen drucken. Sie ist ein separates Handout nur für den Unternehmer-Spieler – sonst sieht jeder Berater die latenten Bedarfe vorab und das Überraschungsmoment des Rollenspiels geht verloren. Im Rollenspiel gibt die Unternehmerrolle Instruktionen auf dem Rollenkarten-Rücken, die nur der Unternehmer-Spieler kennt (z. B. „Nachfolge ist ein echtes Problem, aber Sie sprechen nicht darüber, bis Sie direkt gefragt werden"). Dies erzeugt realistische latente Bedarfe. Fokussierter Beobachtungsauftrag Runde 1: In Runde 1 nur drei Dinge beobachten lassen (der volle 10-Kriterien-Bogen überfordert in 10 Minuten): (1) Verhältnis Berater-Redezeit zu Unternehmer-Redezeit, (2) Wann stellt der Berater eine Frage, deren Antwort ihn überrascht?, (3) Wann geht er von P direkt zur Lösung, ohne eine I-Frage zu stellen? Erst in Runde 2 den vollständigen Bogen einsetzen.</a:t>
+              <a:t>Kernbotschaft: der Berater wählt das Ohr, auf dem er hört – und damit die Wirkung seiner Antwort.</a:t>
+            </a:r>
+          </a:p>
+          <a:p>
+            <a:r>
+              <a:t>Moderation (HB Sec 3): Konkreten Satz aus dem Berufsalltag nehmen: z.B. Unternehmer sagt: „Wir brauchen eigentlich keine neue Finanzierung." Trainer fragt: Was hören Sie auf welchem Ohr? Häufig: TN hören nur auf dem Sachohr. Dann zeigen: Selbstoffenbarung = „Ich habe Angst vor Abhängigkeit"; Appell = „Zeigen Sie mir einen Mehrwert, der meinen Preis wert ist." Typische Teilnehmerreaktion: „Das ist doch Überinterpretation." → Gegenargument: Im Zweifel besser eine Ebene zu viel prüfen als eine zu wenig. Im Firmenkundengeschäft sind offene Gesprächspunkte teuer. Antizipierter Senior-Einwand „Das ist Psychologie, nicht Bankberatung": Dieser Einwand kommt vorhersehbar von erfahrenen TN. Konkrete Antwort (sofort einsetzbar, ohne auf die Übungsphase zu warten): „Das Modell soll keine Therapiesitzung einleiten. Es gibt Ihnen eine Antenne für den Moment, in dem der Kunde zögert, das Thema wechselt oder kürzer als gewohnt antwortet. Wann hatten Sie zuletzt ein Gespräch, in dem der Kunde ‚eigentlich läuft alles gut' gesagt hat – und am Ende war das Ergebnis trotzdem mager? Dann waren Sie auf dem falschen Ohr." Danach direkt in die Kurzübung einsteigen. Rückkopplung in der Kurzübung sichern: Die Kurzübung (Trainer spielt Satz, TN sortieren auf vier Ebenen) endet nicht mit dem Einsammeln der Zettel. Mindestens einen skeptischen TN direkt – einladend, nicht defensiv – ansprechen: „Sie haben schnell abgegeben. Was haben Sie auf dem Appell-Ohr gehört?" Die Antwort ist nicht falsch oder richtig; entscheidend ist, ob er überhaupt eine Ebene außer dem Sachinhalt bemerkt hat. Sonst bleibt die Lernlücke skeptischer TN ungeprüft.</a:t>
             </a:r>
           </a:p>
         </p:txBody>
@@ -720,7 +733,12 @@
           <a:lstStyle/>
           <a:p>
             <a:r>
-              <a:t>Siehe Trainerhandbuch (Sektion 3) für Moderationshinweise, Timing und erwartete Teilnehmerreaktionen.</a:t>
+              <a:t>SPIN deckt latente Bedarfe auf, die der Kunde selbst noch nicht benannt hat.</a:t>
+            </a:r>
+          </a:p>
+          <a:p>
+            <a:r>
+              <a:t>Moderation (HB Sec 3): Bei der Demo: Trainer bricht nach 8–10 Min ab und fragt TN: „Was hat der Berater gut gemacht?" und „Wo hätte er vertiefen sollen?" – dies erhöht die Lernintensität durch Beobachterrolle. Moment-Aufgriff (höchster Lernwert): Falls ein TN während der Demo aus der Rolle tritt und eine Methode kommentiert (z. B. „Das ist eine gute I-Frage"), sofort aufgreifen statt überhören: „Sie sind gerade rausgegangen – was hat Sie bei dieser Frage überrascht?" Kurz pausieren, TN ausreden lassen, dann weiter im Demo-Gespräch. Dieser Moment ist wertvoller als die nächste SPIN-Frage des Trainers. Rollenspiel-Instruktion – Beobachter sind stille Zeugen: Beobachter beobachten schweigend. Kein Unterbrechen, kein Kommentieren während des Gesprächs. Ausnahme: Stopp-Signal ausschließlich durch den Trainer (Handzeichen). Feedback erst in der 5-minütigen Bogen-Besprechung. Instruktion für die TN-Karte: „Als Beobachter sind Sie der stille Zeuge. Ihr Feedback ist das wertvollste am Ende – nicht dazwischen." Hintergrund: Ein Feedback-Kommentar mitten im Gespräch destabilisiert gerade unsichere Berater in dem Moment, in dem sie eine neue Fragetechnik ausprobieren. Rollenkarten-Vorbereitung: Die Rollenkarte mit den latenten Bedarfen (Sec 4.3) nicht in die TN-Unterlagen drucken. Sie ist ein separates Handout nur für den Unternehmer-Spieler – sonst sieht jeder Berater die latenten Bedarfe vorab und das Überraschungsmoment des Rollenspiels geht verloren. Im Rollenspiel gibt die Unternehmerrolle Instruktionen auf dem Rollenkarten-Rücken, die nur der Unternehmer-Spieler kennt (z. B. „Nachfolge ist ein echtes Problem, aber Sie sprechen nicht darüber, bis Sie direkt gefragt werden"). Dies erzeugt realistische latente Bedarfe. Fokussierter Beobachtungsauftrag Runde 1: In Runde 1 nur drei Dinge beobachten lassen (der volle 10-Kriterien-Bogen überfordert in 10 Minuten): (1) Verhältnis Berater-Redezeit zu Unternehmer-Redezeit, (2) Wann stellt der Berater eine Frage, deren Antwort ihn überrascht?, (3) Wann geht er von P direkt zur Lösung, ohne eine I-Frage zu stellen? Erst in Runde 2 den vollständigen Bogen einsetzen.</a:t>
             </a:r>
           </a:p>
         </p:txBody>
@@ -790,7 +808,152 @@
           <a:lstStyle/>
           <a:p>
             <a:r>
+              <a:t>Rollenkarte mit latenten Bedarfen nur an den Unternehmer-Spieler. Debriefing: Welche Frage hat den latenten Bedarf geöffnet? Wo wurde zu früh präsentiert?</a:t>
+            </a:r>
+          </a:p>
+          <a:p>
+            <a:r>
               <a:t>Moderation (HB Sec 3): Bei der Demo: Trainer bricht nach 8–10 Min ab und fragt TN: „Was hat der Berater gut gemacht?" und „Wo hätte er vertiefen sollen?" – dies erhöht die Lernintensität durch Beobachterrolle. Moment-Aufgriff (höchster Lernwert): Falls ein TN während der Demo aus der Rolle tritt und eine Methode kommentiert (z. B. „Das ist eine gute I-Frage"), sofort aufgreifen statt überhören: „Sie sind gerade rausgegangen – was hat Sie bei dieser Frage überrascht?" Kurz pausieren, TN ausreden lassen, dann weiter im Demo-Gespräch. Dieser Moment ist wertvoller als die nächste SPIN-Frage des Trainers. Rollenspiel-Instruktion – Beobachter sind stille Zeugen: Beobachter beobachten schweigend. Kein Unterbrechen, kein Kommentieren während des Gesprächs. Ausnahme: Stopp-Signal ausschließlich durch den Trainer (Handzeichen). Feedback erst in der 5-minütigen Bogen-Besprechung. Instruktion für die TN-Karte: „Als Beobachter sind Sie der stille Zeuge. Ihr Feedback ist das wertvollste am Ende – nicht dazwischen." Hintergrund: Ein Feedback-Kommentar mitten im Gespräch destabilisiert gerade unsichere Berater in dem Moment, in dem sie eine neue Fragetechnik ausprobieren. Rollenkarten-Vorbereitung: Die Rollenkarte mit den latenten Bedarfen (Sec 4.3) nicht in die TN-Unterlagen drucken. Sie ist ein separates Handout nur für den Unternehmer-Spieler – sonst sieht jeder Berater die latenten Bedarfe vorab und das Überraschungsmoment des Rollenspiels geht verloren. Im Rollenspiel gibt die Unternehmerrolle Instruktionen auf dem Rollenkarten-Rücken, die nur der Unternehmer-Spieler kennt (z. B. „Nachfolge ist ein echtes Problem, aber Sie sprechen nicht darüber, bis Sie direkt gefragt werden"). Dies erzeugt realistische latente Bedarfe. Fokussierter Beobachtungsauftrag Runde 1: In Runde 1 nur drei Dinge beobachten lassen (der volle 10-Kriterien-Bogen überfordert in 10 Minuten): (1) Verhältnis Berater-Redezeit zu Unternehmer-Redezeit, (2) Wann stellt der Berater eine Frage, deren Antwort ihn überrascht?, (3) Wann geht er von P direkt zur Lösung, ohne eine I-Frage zu stellen? Erst in Runde 2 den vollständigen Bogen einsetzen.</a:t>
+            </a:r>
+          </a:p>
+        </p:txBody>
+      </p:sp>
+      <p:sp>
+        <p:nvSpPr>
+          <p:cNvPr id="4" name="Slide Number Placeholder 3"/>
+          <p:cNvSpPr>
+            <a:spLocks noGrp="1"/>
+          </p:cNvSpPr>
+          <p:nvPr>
+            <p:ph type="sldNum" idx="5" sz="quarter"/>
+          </p:nvPr>
+        </p:nvSpPr>
+        <p:spPr/>
+      </p:sp>
+    </p:spTree>
+  </p:cSld>
+  <p:clrMapOvr>
+    <a:masterClrMapping/>
+  </p:clrMapOvr>
+</p:notes>
+</file>
+
+<file path=ppt/notesSlides/notesSlide6.xml><?xml version="1.0" encoding="utf-8"?>
+<p:notes xmlns:a="http://schemas.openxmlformats.org/drawingml/2006/main" xmlns:p="http://schemas.openxmlformats.org/presentationml/2006/main" xmlns:r="http://schemas.openxmlformats.org/officeDocument/2006/relationships">
+  <p:cSld>
+    <p:spTree>
+      <p:nvGrpSpPr>
+        <p:cNvPr id="1" name=""/>
+        <p:cNvGrpSpPr/>
+        <p:nvPr/>
+      </p:nvGrpSpPr>
+      <p:grpSpPr>
+        <a:xfrm>
+          <a:off x="0" y="0"/>
+          <a:ext cx="0" cy="0"/>
+          <a:chOff x="0" y="0"/>
+          <a:chExt cx="0" cy="0"/>
+        </a:xfrm>
+      </p:grpSpPr>
+      <p:sp>
+        <p:nvSpPr>
+          <p:cNvPr id="2" name="Slide Image Placeholder 1"/>
+          <p:cNvSpPr>
+            <a:spLocks noGrp="1"/>
+          </p:cNvSpPr>
+          <p:nvPr>
+            <p:ph type="sldImg" idx="2"/>
+          </p:nvPr>
+        </p:nvSpPr>
+        <p:spPr/>
+      </p:sp>
+      <p:sp>
+        <p:nvSpPr>
+          <p:cNvPr id="3" name="Notes Placeholder 2"/>
+          <p:cNvSpPr>
+            <a:spLocks noGrp="1"/>
+          </p:cNvSpPr>
+          <p:nvPr>
+            <p:ph type="body" idx="3" sz="quarter"/>
+          </p:nvPr>
+        </p:nvSpPr>
+        <p:spPr/>
+        <p:txBody>
+          <a:bodyPr/>
+          <a:lstStyle/>
+          <a:p>
+            <a:r>
+              <a:t>Überleitung zum Selbstcheck und Transfer.</a:t>
+            </a:r>
+          </a:p>
+        </p:txBody>
+      </p:sp>
+      <p:sp>
+        <p:nvSpPr>
+          <p:cNvPr id="4" name="Slide Number Placeholder 3"/>
+          <p:cNvSpPr>
+            <a:spLocks noGrp="1"/>
+          </p:cNvSpPr>
+          <p:nvPr>
+            <p:ph type="sldNum" idx="5" sz="quarter"/>
+          </p:nvPr>
+        </p:nvSpPr>
+        <p:spPr/>
+      </p:sp>
+    </p:spTree>
+  </p:cSld>
+  <p:clrMapOvr>
+    <a:masterClrMapping/>
+  </p:clrMapOvr>
+</p:notes>
+</file>
+
+<file path=ppt/notesSlides/notesSlide7.xml><?xml version="1.0" encoding="utf-8"?>
+<p:notes xmlns:a="http://schemas.openxmlformats.org/drawingml/2006/main" xmlns:p="http://schemas.openxmlformats.org/presentationml/2006/main" xmlns:r="http://schemas.openxmlformats.org/officeDocument/2006/relationships">
+  <p:cSld>
+    <p:spTree>
+      <p:nvGrpSpPr>
+        <p:cNvPr id="1" name=""/>
+        <p:cNvGrpSpPr/>
+        <p:nvPr/>
+      </p:nvGrpSpPr>
+      <p:grpSpPr>
+        <a:xfrm>
+          <a:off x="0" y="0"/>
+          <a:ext cx="0" cy="0"/>
+          <a:chOff x="0" y="0"/>
+          <a:chExt cx="0" cy="0"/>
+        </a:xfrm>
+      </p:grpSpPr>
+      <p:sp>
+        <p:nvSpPr>
+          <p:cNvPr id="2" name="Slide Image Placeholder 1"/>
+          <p:cNvSpPr>
+            <a:spLocks noGrp="1"/>
+          </p:cNvSpPr>
+          <p:nvPr>
+            <p:ph type="sldImg" idx="2"/>
+          </p:nvPr>
+        </p:nvSpPr>
+        <p:spPr/>
+      </p:sp>
+      <p:sp>
+        <p:nvSpPr>
+          <p:cNvPr id="3" name="Notes Placeholder 2"/>
+          <p:cNvSpPr>
+            <a:spLocks noGrp="1"/>
+          </p:cNvSpPr>
+          <p:nvPr>
+            <p:ph type="body" idx="3" sz="quarter"/>
+          </p:nvPr>
+        </p:nvSpPr>
+        <p:spPr/>
+        <p:txBody>
+          <a:bodyPr/>
+          <a:lstStyle/>
+          <a:p>
+            <a:r>
+              <a:t>Selbstcheck nach 4 Wochen als Transferanker.</a:t>
             </a:r>
           </a:p>
         </p:txBody>
@@ -4361,6 +4524,1319 @@
 </p:sld>
 </file>
 
+<file path=ppt/slides/slide10.xml><?xml version="1.0" encoding="utf-8"?>
+<p:sld xmlns:a="http://schemas.openxmlformats.org/drawingml/2006/main" xmlns:p="http://schemas.openxmlformats.org/presentationml/2006/main" xmlns:r="http://schemas.openxmlformats.org/officeDocument/2006/relationships">
+  <p:cSld>
+    <p:spTree>
+      <p:nvGrpSpPr>
+        <p:cNvPr id="1" name=""/>
+        <p:cNvGrpSpPr/>
+        <p:nvPr/>
+      </p:nvGrpSpPr>
+      <p:grpSpPr/>
+      <p:sp>
+        <p:nvSpPr>
+          <p:cNvPr id="2" name="Rectangle 1"/>
+          <p:cNvSpPr/>
+          <p:nvPr/>
+        </p:nvSpPr>
+        <p:spPr>
+          <a:xfrm>
+            <a:off x="0" y="0"/>
+            <a:ext cx="12188952" cy="6858000"/>
+          </a:xfrm>
+          <a:prstGeom prst="rect">
+            <a:avLst/>
+          </a:prstGeom>
+          <a:solidFill>
+            <a:srgbClr val="EDEDF3"/>
+          </a:solidFill>
+          <a:ln>
+            <a:noFill/>
+          </a:ln>
+        </p:spPr>
+        <p:style>
+          <a:lnRef idx="1">
+            <a:schemeClr val="accent1"/>
+          </a:lnRef>
+          <a:fillRef idx="3">
+            <a:schemeClr val="accent1"/>
+          </a:fillRef>
+          <a:effectRef idx="2">
+            <a:schemeClr val="accent1"/>
+          </a:effectRef>
+          <a:fontRef idx="minor">
+            <a:schemeClr val="lt1"/>
+          </a:fontRef>
+        </p:style>
+        <p:txBody>
+          <a:bodyPr rtlCol="0" anchor="ctr"/>
+          <a:lstStyle/>
+          <a:p>
+            <a:pPr algn="ctr"/>
+          </a:p>
+        </p:txBody>
+      </p:sp>
+      <p:sp>
+        <p:nvSpPr>
+          <p:cNvPr id="3" name="Rectangle 2"/>
+          <p:cNvSpPr/>
+          <p:nvPr/>
+        </p:nvSpPr>
+        <p:spPr>
+          <a:xfrm>
+            <a:off x="0" y="0"/>
+            <a:ext cx="12188952" cy="50292"/>
+          </a:xfrm>
+          <a:prstGeom prst="rect">
+            <a:avLst/>
+          </a:prstGeom>
+          <a:solidFill>
+            <a:srgbClr val="1F2C56"/>
+          </a:solidFill>
+          <a:ln>
+            <a:noFill/>
+          </a:ln>
+        </p:spPr>
+        <p:style>
+          <a:lnRef idx="1">
+            <a:schemeClr val="accent1"/>
+          </a:lnRef>
+          <a:fillRef idx="3">
+            <a:schemeClr val="accent1"/>
+          </a:fillRef>
+          <a:effectRef idx="2">
+            <a:schemeClr val="accent1"/>
+          </a:effectRef>
+          <a:fontRef idx="minor">
+            <a:schemeClr val="lt1"/>
+          </a:fontRef>
+        </p:style>
+        <p:txBody>
+          <a:bodyPr rtlCol="0" anchor="ctr"/>
+          <a:lstStyle/>
+          <a:p>
+            <a:pPr algn="ctr"/>
+          </a:p>
+        </p:txBody>
+      </p:sp>
+      <p:sp>
+        <p:nvSpPr>
+          <p:cNvPr id="4" name="TextBox 3"/>
+          <p:cNvSpPr txBox="1"/>
+          <p:nvPr/>
+        </p:nvSpPr>
+        <p:spPr>
+          <a:xfrm>
+            <a:off x="685800" y="109728"/>
+            <a:ext cx="10817352" cy="228600"/>
+          </a:xfrm>
+          <a:prstGeom prst="rect">
+            <a:avLst/>
+          </a:prstGeom>
+          <a:noFill/>
+        </p:spPr>
+        <p:txBody>
+          <a:bodyPr wrap="none">
+            <a:spAutoFit/>
+          </a:bodyPr>
+          <a:lstStyle/>
+          <a:p>
+            <a:pPr algn="l"/>
+            <a:r>
+              <a:rPr sz="750">
+                <a:solidFill>
+                  <a:srgbClr val="78808C"/>
+                </a:solidFill>
+                <a:latin typeface="Consolas"/>
+              </a:rPr>
+              <a:t>M10  ·  ARBEITSBLATT</a:t>
+            </a:r>
+          </a:p>
+        </p:txBody>
+      </p:sp>
+      <p:sp>
+        <p:nvSpPr>
+          <p:cNvPr id="5" name="Rectangle 4"/>
+          <p:cNvSpPr/>
+          <p:nvPr/>
+        </p:nvSpPr>
+        <p:spPr>
+          <a:xfrm>
+            <a:off x="0" y="1234440"/>
+            <a:ext cx="12188952" cy="12700"/>
+          </a:xfrm>
+          <a:prstGeom prst="rect">
+            <a:avLst/>
+          </a:prstGeom>
+          <a:solidFill>
+            <a:srgbClr val="D8DFE4"/>
+          </a:solidFill>
+          <a:ln>
+            <a:noFill/>
+          </a:ln>
+        </p:spPr>
+        <p:style>
+          <a:lnRef idx="1">
+            <a:schemeClr val="accent1"/>
+          </a:lnRef>
+          <a:fillRef idx="3">
+            <a:schemeClr val="accent1"/>
+          </a:fillRef>
+          <a:effectRef idx="2">
+            <a:schemeClr val="accent1"/>
+          </a:effectRef>
+          <a:fontRef idx="minor">
+            <a:schemeClr val="lt1"/>
+          </a:fontRef>
+        </p:style>
+        <p:txBody>
+          <a:bodyPr rtlCol="0" anchor="ctr"/>
+          <a:lstStyle/>
+          <a:p>
+            <a:pPr algn="ctr"/>
+          </a:p>
+        </p:txBody>
+      </p:sp>
+      <p:sp>
+        <p:nvSpPr>
+          <p:cNvPr id="6" name="Rectangle 5"/>
+          <p:cNvSpPr/>
+          <p:nvPr/>
+        </p:nvSpPr>
+        <p:spPr>
+          <a:xfrm>
+            <a:off x="685800" y="502920"/>
+            <a:ext cx="36576" cy="658368"/>
+          </a:xfrm>
+          <a:prstGeom prst="rect">
+            <a:avLst/>
+          </a:prstGeom>
+          <a:solidFill>
+            <a:srgbClr val="D9C089"/>
+          </a:solidFill>
+          <a:ln>
+            <a:noFill/>
+          </a:ln>
+        </p:spPr>
+        <p:style>
+          <a:lnRef idx="1">
+            <a:schemeClr val="accent1"/>
+          </a:lnRef>
+          <a:fillRef idx="3">
+            <a:schemeClr val="accent1"/>
+          </a:fillRef>
+          <a:effectRef idx="2">
+            <a:schemeClr val="accent1"/>
+          </a:effectRef>
+          <a:fontRef idx="minor">
+            <a:schemeClr val="lt1"/>
+          </a:fontRef>
+        </p:style>
+        <p:txBody>
+          <a:bodyPr rtlCol="0" anchor="ctr"/>
+          <a:lstStyle/>
+          <a:p>
+            <a:pPr algn="ctr"/>
+          </a:p>
+        </p:txBody>
+      </p:sp>
+      <p:sp>
+        <p:nvSpPr>
+          <p:cNvPr id="7" name="TextBox 6"/>
+          <p:cNvSpPr txBox="1"/>
+          <p:nvPr/>
+        </p:nvSpPr>
+        <p:spPr>
+          <a:xfrm>
+            <a:off x="813816" y="502920"/>
+            <a:ext cx="10634472" cy="685800"/>
+          </a:xfrm>
+          <a:prstGeom prst="rect">
+            <a:avLst/>
+          </a:prstGeom>
+          <a:noFill/>
+        </p:spPr>
+        <p:txBody>
+          <a:bodyPr wrap="square">
+            <a:spAutoFit/>
+          </a:bodyPr>
+          <a:lstStyle/>
+          <a:p>
+            <a:pPr algn="l"/>
+            <a:r>
+              <a:rPr sz="2400" b="1" i="0">
+                <a:solidFill>
+                  <a:srgbClr val="1F2C56"/>
+                </a:solidFill>
+                <a:latin typeface="Arial"/>
+              </a:rPr>
+              <a:t>Rollenspiel Maurer Metallbau bearbeiten</a:t>
+            </a:r>
+          </a:p>
+        </p:txBody>
+      </p:sp>
+      <p:sp>
+        <p:nvSpPr>
+          <p:cNvPr id="8" name="TextBox 7"/>
+          <p:cNvSpPr txBox="1"/>
+          <p:nvPr/>
+        </p:nvSpPr>
+        <p:spPr>
+          <a:xfrm>
+            <a:off x="685800" y="1554480"/>
+            <a:ext cx="10817352" cy="3840480"/>
+          </a:xfrm>
+          <a:prstGeom prst="rect">
+            <a:avLst/>
+          </a:prstGeom>
+          <a:noFill/>
+        </p:spPr>
+        <p:txBody>
+          <a:bodyPr wrap="square">
+            <a:spAutoFit/>
+          </a:bodyPr>
+          <a:lstStyle/>
+          <a:p>
+            <a:pPr marL="190500" indent="-190500">
+              <a:spcBef>
+                <a:spcPts val="400"/>
+              </a:spcBef>
+              <a:spcAft>
+                <a:spcPts val="200"/>
+              </a:spcAft>
+            </a:pPr>
+            <a:r>
+              <a:rPr sz="1400">
+                <a:solidFill>
+                  <a:srgbClr val="3D5466"/>
+                </a:solidFill>
+                <a:latin typeface="Arial"/>
+              </a:rPr>
+              <a:t>▸  Führen Sie das Kundengespräch mit Florian Maurer im Rollenspiel.</a:t>
+            </a:r>
+          </a:p>
+          <a:p>
+            <a:pPr marL="190500" indent="-190500">
+              <a:spcBef>
+                <a:spcPts val="400"/>
+              </a:spcBef>
+              <a:spcAft>
+                <a:spcPts val="200"/>
+              </a:spcAft>
+            </a:pPr>
+            <a:r>
+              <a:rPr sz="1400">
+                <a:solidFill>
+                  <a:srgbClr val="3D5466"/>
+                </a:solidFill>
+                <a:latin typeface="Arial"/>
+              </a:rPr>
+              <a:t>▸  Hören Sie auf allen vier Ohren und decken Sie mit SPIN die latenten Bedarfe auf.</a:t>
+            </a:r>
+          </a:p>
+          <a:p>
+            <a:pPr marL="190500" indent="-190500">
+              <a:spcBef>
+                <a:spcPts val="400"/>
+              </a:spcBef>
+              <a:spcAft>
+                <a:spcPts val="200"/>
+              </a:spcAft>
+            </a:pPr>
+            <a:r>
+              <a:rPr sz="1400">
+                <a:solidFill>
+                  <a:srgbClr val="3D5466"/>
+                </a:solidFill>
+                <a:latin typeface="Arial"/>
+              </a:rPr>
+              <a:t>▸  Nutzen Sie den Beobachtungsbogen als dritter Rollenspieler für strukturiertes Feedback (AB-1).</a:t>
+            </a:r>
+          </a:p>
+        </p:txBody>
+      </p:sp>
+      <p:sp>
+        <p:nvSpPr>
+          <p:cNvPr id="9" name="Rectangle 8"/>
+          <p:cNvSpPr/>
+          <p:nvPr/>
+        </p:nvSpPr>
+        <p:spPr>
+          <a:xfrm>
+            <a:off x="685800" y="5486400"/>
+            <a:ext cx="10817352" cy="640080"/>
+          </a:xfrm>
+          <a:prstGeom prst="rect">
+            <a:avLst/>
+          </a:prstGeom>
+          <a:solidFill>
+            <a:srgbClr val="1F2C56"/>
+          </a:solidFill>
+          <a:ln>
+            <a:noFill/>
+          </a:ln>
+        </p:spPr>
+        <p:style>
+          <a:lnRef idx="1">
+            <a:schemeClr val="accent1"/>
+          </a:lnRef>
+          <a:fillRef idx="3">
+            <a:schemeClr val="accent1"/>
+          </a:fillRef>
+          <a:effectRef idx="2">
+            <a:schemeClr val="accent1"/>
+          </a:effectRef>
+          <a:fontRef idx="minor">
+            <a:schemeClr val="lt1"/>
+          </a:fontRef>
+        </p:style>
+        <p:txBody>
+          <a:bodyPr rtlCol="0" anchor="ctr"/>
+          <a:lstStyle/>
+          <a:p>
+            <a:pPr algn="ctr"/>
+          </a:p>
+        </p:txBody>
+      </p:sp>
+      <p:sp>
+        <p:nvSpPr>
+          <p:cNvPr id="10" name="TextBox 9"/>
+          <p:cNvSpPr txBox="1"/>
+          <p:nvPr/>
+        </p:nvSpPr>
+        <p:spPr>
+          <a:xfrm>
+            <a:off x="868680" y="5596128"/>
+            <a:ext cx="10451592" cy="457200"/>
+          </a:xfrm>
+          <a:prstGeom prst="rect">
+            <a:avLst/>
+          </a:prstGeom>
+          <a:noFill/>
+        </p:spPr>
+        <p:txBody>
+          <a:bodyPr wrap="square">
+            <a:spAutoFit/>
+          </a:bodyPr>
+          <a:lstStyle/>
+          <a:p>
+            <a:pPr algn="l"/>
+            <a:r>
+              <a:rPr sz="1300" b="1" i="0">
+                <a:solidFill>
+                  <a:srgbClr val="FFFFFF"/>
+                </a:solidFill>
+                <a:latin typeface="Arial"/>
+              </a:rPr>
+              <a:t>→  Bearbeitung im Teilnehmer-Workbook (Arbeitsblatt mit Ausfüllfeldern)</a:t>
+            </a:r>
+          </a:p>
+        </p:txBody>
+      </p:sp>
+      <p:sp>
+        <p:nvSpPr>
+          <p:cNvPr id="11" name="Rectangle 10"/>
+          <p:cNvSpPr/>
+          <p:nvPr/>
+        </p:nvSpPr>
+        <p:spPr>
+          <a:xfrm>
+            <a:off x="0" y="6510528"/>
+            <a:ext cx="12188952" cy="347472"/>
+          </a:xfrm>
+          <a:prstGeom prst="rect">
+            <a:avLst/>
+          </a:prstGeom>
+          <a:solidFill>
+            <a:srgbClr val="0A1937"/>
+          </a:solidFill>
+          <a:ln>
+            <a:noFill/>
+          </a:ln>
+        </p:spPr>
+        <p:style>
+          <a:lnRef idx="1">
+            <a:schemeClr val="accent1"/>
+          </a:lnRef>
+          <a:fillRef idx="3">
+            <a:schemeClr val="accent1"/>
+          </a:fillRef>
+          <a:effectRef idx="2">
+            <a:schemeClr val="accent1"/>
+          </a:effectRef>
+          <a:fontRef idx="minor">
+            <a:schemeClr val="lt1"/>
+          </a:fontRef>
+        </p:style>
+        <p:txBody>
+          <a:bodyPr rtlCol="0" anchor="ctr"/>
+          <a:lstStyle/>
+          <a:p>
+            <a:pPr algn="ctr"/>
+          </a:p>
+        </p:txBody>
+      </p:sp>
+      <p:sp>
+        <p:nvSpPr>
+          <p:cNvPr id="12" name="TextBox 11"/>
+          <p:cNvSpPr txBox="1"/>
+          <p:nvPr/>
+        </p:nvSpPr>
+        <p:spPr>
+          <a:xfrm>
+            <a:off x="685800" y="6583680"/>
+            <a:ext cx="6490411" cy="256032"/>
+          </a:xfrm>
+          <a:prstGeom prst="rect">
+            <a:avLst/>
+          </a:prstGeom>
+          <a:noFill/>
+        </p:spPr>
+        <p:txBody>
+          <a:bodyPr wrap="none">
+            <a:spAutoFit/>
+          </a:bodyPr>
+          <a:lstStyle/>
+          <a:p>
+            <a:pPr algn="l"/>
+            <a:r>
+              <a:rPr sz="700">
+                <a:solidFill>
+                  <a:srgbClr val="A0B4D2"/>
+                </a:solidFill>
+                <a:latin typeface="Consolas"/>
+              </a:rPr>
+              <a:t>FKB Campus  ·  M10</a:t>
+            </a:r>
+          </a:p>
+        </p:txBody>
+      </p:sp>
+    </p:spTree>
+  </p:cSld>
+  <p:clrMapOvr>
+    <a:masterClrMapping/>
+  </p:clrMapOvr>
+</p:sld>
+</file>
+
+<file path=ppt/slides/slide11.xml><?xml version="1.0" encoding="utf-8"?>
+<p:sld xmlns:a="http://schemas.openxmlformats.org/drawingml/2006/main" xmlns:p="http://schemas.openxmlformats.org/presentationml/2006/main" xmlns:r="http://schemas.openxmlformats.org/officeDocument/2006/relationships">
+  <p:cSld>
+    <p:spTree>
+      <p:nvGrpSpPr>
+        <p:cNvPr id="1" name=""/>
+        <p:cNvGrpSpPr/>
+        <p:nvPr/>
+      </p:nvGrpSpPr>
+      <p:grpSpPr/>
+      <p:sp>
+        <p:nvSpPr>
+          <p:cNvPr id="2" name="Rectangle 1"/>
+          <p:cNvSpPr/>
+          <p:nvPr/>
+        </p:nvSpPr>
+        <p:spPr>
+          <a:xfrm>
+            <a:off x="0" y="0"/>
+            <a:ext cx="12188952" cy="6858000"/>
+          </a:xfrm>
+          <a:prstGeom prst="rect">
+            <a:avLst/>
+          </a:prstGeom>
+          <a:solidFill>
+            <a:srgbClr val="EDEDF3"/>
+          </a:solidFill>
+          <a:ln>
+            <a:noFill/>
+          </a:ln>
+        </p:spPr>
+        <p:style>
+          <a:lnRef idx="1">
+            <a:schemeClr val="accent1"/>
+          </a:lnRef>
+          <a:fillRef idx="3">
+            <a:schemeClr val="accent1"/>
+          </a:fillRef>
+          <a:effectRef idx="2">
+            <a:schemeClr val="accent1"/>
+          </a:effectRef>
+          <a:fontRef idx="minor">
+            <a:schemeClr val="lt1"/>
+          </a:fontRef>
+        </p:style>
+        <p:txBody>
+          <a:bodyPr rtlCol="0" anchor="ctr"/>
+          <a:lstStyle/>
+          <a:p>
+            <a:pPr algn="ctr"/>
+          </a:p>
+        </p:txBody>
+      </p:sp>
+      <p:sp>
+        <p:nvSpPr>
+          <p:cNvPr id="3" name="Rectangle 2"/>
+          <p:cNvSpPr/>
+          <p:nvPr/>
+        </p:nvSpPr>
+        <p:spPr>
+          <a:xfrm>
+            <a:off x="0" y="0"/>
+            <a:ext cx="12188952" cy="50292"/>
+          </a:xfrm>
+          <a:prstGeom prst="rect">
+            <a:avLst/>
+          </a:prstGeom>
+          <a:solidFill>
+            <a:srgbClr val="1F2C56"/>
+          </a:solidFill>
+          <a:ln>
+            <a:noFill/>
+          </a:ln>
+        </p:spPr>
+        <p:style>
+          <a:lnRef idx="1">
+            <a:schemeClr val="accent1"/>
+          </a:lnRef>
+          <a:fillRef idx="3">
+            <a:schemeClr val="accent1"/>
+          </a:fillRef>
+          <a:effectRef idx="2">
+            <a:schemeClr val="accent1"/>
+          </a:effectRef>
+          <a:fontRef idx="minor">
+            <a:schemeClr val="lt1"/>
+          </a:fontRef>
+        </p:style>
+        <p:txBody>
+          <a:bodyPr rtlCol="0" anchor="ctr"/>
+          <a:lstStyle/>
+          <a:p>
+            <a:pPr algn="ctr"/>
+          </a:p>
+        </p:txBody>
+      </p:sp>
+      <p:sp>
+        <p:nvSpPr>
+          <p:cNvPr id="4" name="TextBox 3"/>
+          <p:cNvSpPr txBox="1"/>
+          <p:nvPr/>
+        </p:nvSpPr>
+        <p:spPr>
+          <a:xfrm>
+            <a:off x="685800" y="109728"/>
+            <a:ext cx="10817352" cy="228600"/>
+          </a:xfrm>
+          <a:prstGeom prst="rect">
+            <a:avLst/>
+          </a:prstGeom>
+          <a:noFill/>
+        </p:spPr>
+        <p:txBody>
+          <a:bodyPr wrap="none">
+            <a:spAutoFit/>
+          </a:bodyPr>
+          <a:lstStyle/>
+          <a:p>
+            <a:pPr algn="l"/>
+            <a:r>
+              <a:rPr sz="750">
+                <a:solidFill>
+                  <a:srgbClr val="78808C"/>
+                </a:solidFill>
+                <a:latin typeface="Consolas"/>
+              </a:rPr>
+              <a:t>M10  ·  INHALT</a:t>
+            </a:r>
+          </a:p>
+        </p:txBody>
+      </p:sp>
+      <p:sp>
+        <p:nvSpPr>
+          <p:cNvPr id="5" name="Rectangle 4"/>
+          <p:cNvSpPr/>
+          <p:nvPr/>
+        </p:nvSpPr>
+        <p:spPr>
+          <a:xfrm>
+            <a:off x="0" y="1234440"/>
+            <a:ext cx="12188952" cy="12700"/>
+          </a:xfrm>
+          <a:prstGeom prst="rect">
+            <a:avLst/>
+          </a:prstGeom>
+          <a:solidFill>
+            <a:srgbClr val="D8DFE4"/>
+          </a:solidFill>
+          <a:ln>
+            <a:noFill/>
+          </a:ln>
+        </p:spPr>
+        <p:style>
+          <a:lnRef idx="1">
+            <a:schemeClr val="accent1"/>
+          </a:lnRef>
+          <a:fillRef idx="3">
+            <a:schemeClr val="accent1"/>
+          </a:fillRef>
+          <a:effectRef idx="2">
+            <a:schemeClr val="accent1"/>
+          </a:effectRef>
+          <a:fontRef idx="minor">
+            <a:schemeClr val="lt1"/>
+          </a:fontRef>
+        </p:style>
+        <p:txBody>
+          <a:bodyPr rtlCol="0" anchor="ctr"/>
+          <a:lstStyle/>
+          <a:p>
+            <a:pPr algn="ctr"/>
+          </a:p>
+        </p:txBody>
+      </p:sp>
+      <p:sp>
+        <p:nvSpPr>
+          <p:cNvPr id="6" name="Rectangle 5"/>
+          <p:cNvSpPr/>
+          <p:nvPr/>
+        </p:nvSpPr>
+        <p:spPr>
+          <a:xfrm>
+            <a:off x="685800" y="502920"/>
+            <a:ext cx="36576" cy="658368"/>
+          </a:xfrm>
+          <a:prstGeom prst="rect">
+            <a:avLst/>
+          </a:prstGeom>
+          <a:solidFill>
+            <a:srgbClr val="D9C089"/>
+          </a:solidFill>
+          <a:ln>
+            <a:noFill/>
+          </a:ln>
+        </p:spPr>
+        <p:style>
+          <a:lnRef idx="1">
+            <a:schemeClr val="accent1"/>
+          </a:lnRef>
+          <a:fillRef idx="3">
+            <a:schemeClr val="accent1"/>
+          </a:fillRef>
+          <a:effectRef idx="2">
+            <a:schemeClr val="accent1"/>
+          </a:effectRef>
+          <a:fontRef idx="minor">
+            <a:schemeClr val="lt1"/>
+          </a:fontRef>
+        </p:style>
+        <p:txBody>
+          <a:bodyPr rtlCol="0" anchor="ctr"/>
+          <a:lstStyle/>
+          <a:p>
+            <a:pPr algn="ctr"/>
+          </a:p>
+        </p:txBody>
+      </p:sp>
+      <p:sp>
+        <p:nvSpPr>
+          <p:cNvPr id="7" name="TextBox 6"/>
+          <p:cNvSpPr txBox="1"/>
+          <p:nvPr/>
+        </p:nvSpPr>
+        <p:spPr>
+          <a:xfrm>
+            <a:off x="813816" y="502920"/>
+            <a:ext cx="10634472" cy="685800"/>
+          </a:xfrm>
+          <a:prstGeom prst="rect">
+            <a:avLst/>
+          </a:prstGeom>
+          <a:noFill/>
+        </p:spPr>
+        <p:txBody>
+          <a:bodyPr wrap="square">
+            <a:spAutoFit/>
+          </a:bodyPr>
+          <a:lstStyle/>
+          <a:p>
+            <a:pPr algn="l"/>
+            <a:r>
+              <a:rPr sz="2400" b="1" i="0">
+                <a:solidFill>
+                  <a:srgbClr val="1F2C56"/>
+                </a:solidFill>
+                <a:latin typeface="Arial"/>
+              </a:rPr>
+              <a:t>Prinzip dieses Moduls</a:t>
+            </a:r>
+          </a:p>
+        </p:txBody>
+      </p:sp>
+      <p:sp>
+        <p:nvSpPr>
+          <p:cNvPr id="8" name="TextBox 7"/>
+          <p:cNvSpPr txBox="1"/>
+          <p:nvPr/>
+        </p:nvSpPr>
+        <p:spPr>
+          <a:xfrm>
+            <a:off x="685800" y="1417320"/>
+            <a:ext cx="10817352" cy="4892040"/>
+          </a:xfrm>
+          <a:prstGeom prst="rect">
+            <a:avLst/>
+          </a:prstGeom>
+          <a:noFill/>
+        </p:spPr>
+        <p:txBody>
+          <a:bodyPr wrap="square" anchor="ctr">
+            <a:spAutoFit/>
+          </a:bodyPr>
+          <a:lstStyle/>
+          <a:p>
+            <a:pPr marL="177800" indent="-177800">
+              <a:spcBef>
+                <a:spcPts val="600"/>
+              </a:spcBef>
+              <a:spcAft>
+                <a:spcPts val="200"/>
+              </a:spcAft>
+            </a:pPr>
+            <a:r>
+              <a:rPr sz="1200" i="1">
+                <a:solidFill>
+                  <a:srgbClr val="3D5466"/>
+                </a:solidFill>
+                <a:latin typeface="Arial"/>
+              </a:rPr>
+              <a:t>→  Hinter jeder Sachaussage steckt eine Botschaft – hör auf allen vier Ohren.</a:t>
+            </a:r>
+          </a:p>
+          <a:p>
+            <a:pPr marL="190500" indent="-190500">
+              <a:spcBef>
+                <a:spcPts val="400"/>
+              </a:spcBef>
+              <a:spcAft>
+                <a:spcPts val="200"/>
+              </a:spcAft>
+            </a:pPr>
+            <a:r>
+              <a:rPr sz="1300">
+                <a:solidFill>
+                  <a:srgbClr val="3D5466"/>
+                </a:solidFill>
+                <a:latin typeface="Arial"/>
+              </a:rPr>
+              <a:t>▸  Der eigentliche Bedarf liegt selten in dem, was der Kunde sagt, sondern in dem, was er meint (Schulz von Thun).</a:t>
+            </a:r>
+          </a:p>
+        </p:txBody>
+      </p:sp>
+      <p:sp>
+        <p:nvSpPr>
+          <p:cNvPr id="9" name="Rectangle 8"/>
+          <p:cNvSpPr/>
+          <p:nvPr/>
+        </p:nvSpPr>
+        <p:spPr>
+          <a:xfrm>
+            <a:off x="0" y="6510528"/>
+            <a:ext cx="12188952" cy="347472"/>
+          </a:xfrm>
+          <a:prstGeom prst="rect">
+            <a:avLst/>
+          </a:prstGeom>
+          <a:solidFill>
+            <a:srgbClr val="0A1937"/>
+          </a:solidFill>
+          <a:ln>
+            <a:noFill/>
+          </a:ln>
+        </p:spPr>
+        <p:style>
+          <a:lnRef idx="1">
+            <a:schemeClr val="accent1"/>
+          </a:lnRef>
+          <a:fillRef idx="3">
+            <a:schemeClr val="accent1"/>
+          </a:fillRef>
+          <a:effectRef idx="2">
+            <a:schemeClr val="accent1"/>
+          </a:effectRef>
+          <a:fontRef idx="minor">
+            <a:schemeClr val="lt1"/>
+          </a:fontRef>
+        </p:style>
+        <p:txBody>
+          <a:bodyPr rtlCol="0" anchor="ctr"/>
+          <a:lstStyle/>
+          <a:p>
+            <a:pPr algn="ctr"/>
+          </a:p>
+        </p:txBody>
+      </p:sp>
+      <p:sp>
+        <p:nvSpPr>
+          <p:cNvPr id="10" name="TextBox 9"/>
+          <p:cNvSpPr txBox="1"/>
+          <p:nvPr/>
+        </p:nvSpPr>
+        <p:spPr>
+          <a:xfrm>
+            <a:off x="685800" y="6583680"/>
+            <a:ext cx="6490411" cy="256032"/>
+          </a:xfrm>
+          <a:prstGeom prst="rect">
+            <a:avLst/>
+          </a:prstGeom>
+          <a:noFill/>
+        </p:spPr>
+        <p:txBody>
+          <a:bodyPr wrap="none">
+            <a:spAutoFit/>
+          </a:bodyPr>
+          <a:lstStyle/>
+          <a:p>
+            <a:pPr algn="l"/>
+            <a:r>
+              <a:rPr sz="700">
+                <a:solidFill>
+                  <a:srgbClr val="A0B4D2"/>
+                </a:solidFill>
+                <a:latin typeface="Consolas"/>
+              </a:rPr>
+              <a:t>FKB Campus  ·  M10</a:t>
+            </a:r>
+          </a:p>
+        </p:txBody>
+      </p:sp>
+    </p:spTree>
+  </p:cSld>
+  <p:clrMapOvr>
+    <a:masterClrMapping/>
+  </p:clrMapOvr>
+</p:sld>
+</file>
+
+<file path=ppt/slides/slide12.xml><?xml version="1.0" encoding="utf-8"?>
+<p:sld xmlns:a="http://schemas.openxmlformats.org/drawingml/2006/main" xmlns:p="http://schemas.openxmlformats.org/presentationml/2006/main" xmlns:r="http://schemas.openxmlformats.org/officeDocument/2006/relationships">
+  <p:cSld>
+    <p:spTree>
+      <p:nvGrpSpPr>
+        <p:cNvPr id="1" name=""/>
+        <p:cNvGrpSpPr/>
+        <p:nvPr/>
+      </p:nvGrpSpPr>
+      <p:grpSpPr/>
+      <p:sp>
+        <p:nvSpPr>
+          <p:cNvPr id="2" name="Rectangle 1"/>
+          <p:cNvSpPr/>
+          <p:nvPr/>
+        </p:nvSpPr>
+        <p:spPr>
+          <a:xfrm>
+            <a:off x="0" y="0"/>
+            <a:ext cx="12188952" cy="6858000"/>
+          </a:xfrm>
+          <a:prstGeom prst="rect">
+            <a:avLst/>
+          </a:prstGeom>
+          <a:solidFill>
+            <a:srgbClr val="EDEDF3"/>
+          </a:solidFill>
+          <a:ln>
+            <a:noFill/>
+          </a:ln>
+        </p:spPr>
+        <p:style>
+          <a:lnRef idx="1">
+            <a:schemeClr val="accent1"/>
+          </a:lnRef>
+          <a:fillRef idx="3">
+            <a:schemeClr val="accent1"/>
+          </a:fillRef>
+          <a:effectRef idx="2">
+            <a:schemeClr val="accent1"/>
+          </a:effectRef>
+          <a:fontRef idx="minor">
+            <a:schemeClr val="lt1"/>
+          </a:fontRef>
+        </p:style>
+        <p:txBody>
+          <a:bodyPr rtlCol="0" anchor="ctr"/>
+          <a:lstStyle/>
+          <a:p>
+            <a:pPr algn="ctr"/>
+          </a:p>
+        </p:txBody>
+      </p:sp>
+      <p:sp>
+        <p:nvSpPr>
+          <p:cNvPr id="3" name="Rectangle 2"/>
+          <p:cNvSpPr/>
+          <p:nvPr/>
+        </p:nvSpPr>
+        <p:spPr>
+          <a:xfrm>
+            <a:off x="0" y="0"/>
+            <a:ext cx="12188952" cy="50292"/>
+          </a:xfrm>
+          <a:prstGeom prst="rect">
+            <a:avLst/>
+          </a:prstGeom>
+          <a:solidFill>
+            <a:srgbClr val="1F2C56"/>
+          </a:solidFill>
+          <a:ln>
+            <a:noFill/>
+          </a:ln>
+        </p:spPr>
+        <p:style>
+          <a:lnRef idx="1">
+            <a:schemeClr val="accent1"/>
+          </a:lnRef>
+          <a:fillRef idx="3">
+            <a:schemeClr val="accent1"/>
+          </a:fillRef>
+          <a:effectRef idx="2">
+            <a:schemeClr val="accent1"/>
+          </a:effectRef>
+          <a:fontRef idx="minor">
+            <a:schemeClr val="lt1"/>
+          </a:fontRef>
+        </p:style>
+        <p:txBody>
+          <a:bodyPr rtlCol="0" anchor="ctr"/>
+          <a:lstStyle/>
+          <a:p>
+            <a:pPr algn="ctr"/>
+          </a:p>
+        </p:txBody>
+      </p:sp>
+      <p:sp>
+        <p:nvSpPr>
+          <p:cNvPr id="4" name="TextBox 3"/>
+          <p:cNvSpPr txBox="1"/>
+          <p:nvPr/>
+        </p:nvSpPr>
+        <p:spPr>
+          <a:xfrm>
+            <a:off x="685800" y="109728"/>
+            <a:ext cx="10817352" cy="228600"/>
+          </a:xfrm>
+          <a:prstGeom prst="rect">
+            <a:avLst/>
+          </a:prstGeom>
+          <a:noFill/>
+        </p:spPr>
+        <p:txBody>
+          <a:bodyPr wrap="none">
+            <a:spAutoFit/>
+          </a:bodyPr>
+          <a:lstStyle/>
+          <a:p>
+            <a:pPr algn="l"/>
+            <a:r>
+              <a:rPr sz="750">
+                <a:solidFill>
+                  <a:srgbClr val="78808C"/>
+                </a:solidFill>
+                <a:latin typeface="Consolas"/>
+              </a:rPr>
+              <a:t>M10  ·  INHALT</a:t>
+            </a:r>
+          </a:p>
+        </p:txBody>
+      </p:sp>
+      <p:sp>
+        <p:nvSpPr>
+          <p:cNvPr id="5" name="Rectangle 4"/>
+          <p:cNvSpPr/>
+          <p:nvPr/>
+        </p:nvSpPr>
+        <p:spPr>
+          <a:xfrm>
+            <a:off x="0" y="1234440"/>
+            <a:ext cx="12188952" cy="12700"/>
+          </a:xfrm>
+          <a:prstGeom prst="rect">
+            <a:avLst/>
+          </a:prstGeom>
+          <a:solidFill>
+            <a:srgbClr val="D8DFE4"/>
+          </a:solidFill>
+          <a:ln>
+            <a:noFill/>
+          </a:ln>
+        </p:spPr>
+        <p:style>
+          <a:lnRef idx="1">
+            <a:schemeClr val="accent1"/>
+          </a:lnRef>
+          <a:fillRef idx="3">
+            <a:schemeClr val="accent1"/>
+          </a:fillRef>
+          <a:effectRef idx="2">
+            <a:schemeClr val="accent1"/>
+          </a:effectRef>
+          <a:fontRef idx="minor">
+            <a:schemeClr val="lt1"/>
+          </a:fontRef>
+        </p:style>
+        <p:txBody>
+          <a:bodyPr rtlCol="0" anchor="ctr"/>
+          <a:lstStyle/>
+          <a:p>
+            <a:pPr algn="ctr"/>
+          </a:p>
+        </p:txBody>
+      </p:sp>
+      <p:sp>
+        <p:nvSpPr>
+          <p:cNvPr id="6" name="Rectangle 5"/>
+          <p:cNvSpPr/>
+          <p:nvPr/>
+        </p:nvSpPr>
+        <p:spPr>
+          <a:xfrm>
+            <a:off x="685800" y="502920"/>
+            <a:ext cx="36576" cy="658368"/>
+          </a:xfrm>
+          <a:prstGeom prst="rect">
+            <a:avLst/>
+          </a:prstGeom>
+          <a:solidFill>
+            <a:srgbClr val="D9C089"/>
+          </a:solidFill>
+          <a:ln>
+            <a:noFill/>
+          </a:ln>
+        </p:spPr>
+        <p:style>
+          <a:lnRef idx="1">
+            <a:schemeClr val="accent1"/>
+          </a:lnRef>
+          <a:fillRef idx="3">
+            <a:schemeClr val="accent1"/>
+          </a:fillRef>
+          <a:effectRef idx="2">
+            <a:schemeClr val="accent1"/>
+          </a:effectRef>
+          <a:fontRef idx="minor">
+            <a:schemeClr val="lt1"/>
+          </a:fontRef>
+        </p:style>
+        <p:txBody>
+          <a:bodyPr rtlCol="0" anchor="ctr"/>
+          <a:lstStyle/>
+          <a:p>
+            <a:pPr algn="ctr"/>
+          </a:p>
+        </p:txBody>
+      </p:sp>
+      <p:sp>
+        <p:nvSpPr>
+          <p:cNvPr id="7" name="TextBox 6"/>
+          <p:cNvSpPr txBox="1"/>
+          <p:nvPr/>
+        </p:nvSpPr>
+        <p:spPr>
+          <a:xfrm>
+            <a:off x="813816" y="502920"/>
+            <a:ext cx="10634472" cy="685800"/>
+          </a:xfrm>
+          <a:prstGeom prst="rect">
+            <a:avLst/>
+          </a:prstGeom>
+          <a:noFill/>
+        </p:spPr>
+        <p:txBody>
+          <a:bodyPr wrap="square">
+            <a:spAutoFit/>
+          </a:bodyPr>
+          <a:lstStyle/>
+          <a:p>
+            <a:pPr algn="l"/>
+            <a:r>
+              <a:rPr sz="2400" b="1" i="0">
+                <a:solidFill>
+                  <a:srgbClr val="1F2C56"/>
+                </a:solidFill>
+                <a:latin typeface="Arial"/>
+              </a:rPr>
+              <a:t>Reflexion und Selbstcheck</a:t>
+            </a:r>
+          </a:p>
+        </p:txBody>
+      </p:sp>
+      <p:sp>
+        <p:nvSpPr>
+          <p:cNvPr id="8" name="TextBox 7"/>
+          <p:cNvSpPr txBox="1"/>
+          <p:nvPr/>
+        </p:nvSpPr>
+        <p:spPr>
+          <a:xfrm>
+            <a:off x="685800" y="1417320"/>
+            <a:ext cx="10817352" cy="4892040"/>
+          </a:xfrm>
+          <a:prstGeom prst="rect">
+            <a:avLst/>
+          </a:prstGeom>
+          <a:noFill/>
+        </p:spPr>
+        <p:txBody>
+          <a:bodyPr wrap="square" anchor="ctr">
+            <a:spAutoFit/>
+          </a:bodyPr>
+          <a:lstStyle/>
+          <a:p>
+            <a:pPr marL="190500" indent="-190500">
+              <a:spcBef>
+                <a:spcPts val="400"/>
+              </a:spcBef>
+              <a:spcAft>
+                <a:spcPts val="200"/>
+              </a:spcAft>
+            </a:pPr>
+            <a:r>
+              <a:rPr sz="1300">
+                <a:solidFill>
+                  <a:srgbClr val="3D5466"/>
+                </a:solidFill>
+                <a:latin typeface="Arial"/>
+              </a:rPr>
+              <a:t>▸  Auf welchem Ohr hören Sie im Alltag am häufigsten – und welches vernachlässigen Sie?</a:t>
+            </a:r>
+          </a:p>
+          <a:p>
+            <a:pPr marL="190500" indent="-190500">
+              <a:spcBef>
+                <a:spcPts val="400"/>
+              </a:spcBef>
+              <a:spcAft>
+                <a:spcPts val="200"/>
+              </a:spcAft>
+            </a:pPr>
+            <a:r>
+              <a:rPr sz="1300">
+                <a:solidFill>
+                  <a:srgbClr val="3D5466"/>
+                </a:solidFill>
+                <a:latin typeface="Arial"/>
+              </a:rPr>
+              <a:t>▸  Welchen latenten Bedarf haben Sie zuletzt übersehen, weil Sie zu früh präsentiert haben?</a:t>
+            </a:r>
+          </a:p>
+          <a:p>
+            <a:pPr marL="190500" indent="-190500">
+              <a:spcBef>
+                <a:spcPts val="400"/>
+              </a:spcBef>
+              <a:spcAft>
+                <a:spcPts val="200"/>
+              </a:spcAft>
+            </a:pPr>
+            <a:r>
+              <a:rPr sz="1300">
+                <a:solidFill>
+                  <a:srgbClr val="3D5466"/>
+                </a:solidFill>
+                <a:latin typeface="Arial"/>
+              </a:rPr>
+              <a:t>▸  Welche SPIN-Frage nehmen Sie fest in Ihr nächstes Gespräch mit?</a:t>
+            </a:r>
+          </a:p>
+        </p:txBody>
+      </p:sp>
+      <p:sp>
+        <p:nvSpPr>
+          <p:cNvPr id="9" name="Rectangle 8"/>
+          <p:cNvSpPr/>
+          <p:nvPr/>
+        </p:nvSpPr>
+        <p:spPr>
+          <a:xfrm>
+            <a:off x="0" y="6510528"/>
+            <a:ext cx="12188952" cy="347472"/>
+          </a:xfrm>
+          <a:prstGeom prst="rect">
+            <a:avLst/>
+          </a:prstGeom>
+          <a:solidFill>
+            <a:srgbClr val="0A1937"/>
+          </a:solidFill>
+          <a:ln>
+            <a:noFill/>
+          </a:ln>
+        </p:spPr>
+        <p:style>
+          <a:lnRef idx="1">
+            <a:schemeClr val="accent1"/>
+          </a:lnRef>
+          <a:fillRef idx="3">
+            <a:schemeClr val="accent1"/>
+          </a:fillRef>
+          <a:effectRef idx="2">
+            <a:schemeClr val="accent1"/>
+          </a:effectRef>
+          <a:fontRef idx="minor">
+            <a:schemeClr val="lt1"/>
+          </a:fontRef>
+        </p:style>
+        <p:txBody>
+          <a:bodyPr rtlCol="0" anchor="ctr"/>
+          <a:lstStyle/>
+          <a:p>
+            <a:pPr algn="ctr"/>
+          </a:p>
+        </p:txBody>
+      </p:sp>
+      <p:sp>
+        <p:nvSpPr>
+          <p:cNvPr id="10" name="TextBox 9"/>
+          <p:cNvSpPr txBox="1"/>
+          <p:nvPr/>
+        </p:nvSpPr>
+        <p:spPr>
+          <a:xfrm>
+            <a:off x="685800" y="6583680"/>
+            <a:ext cx="6490411" cy="256032"/>
+          </a:xfrm>
+          <a:prstGeom prst="rect">
+            <a:avLst/>
+          </a:prstGeom>
+          <a:noFill/>
+        </p:spPr>
+        <p:txBody>
+          <a:bodyPr wrap="none">
+            <a:spAutoFit/>
+          </a:bodyPr>
+          <a:lstStyle/>
+          <a:p>
+            <a:pPr algn="l"/>
+            <a:r>
+              <a:rPr sz="700">
+                <a:solidFill>
+                  <a:srgbClr val="A0B4D2"/>
+                </a:solidFill>
+                <a:latin typeface="Consolas"/>
+              </a:rPr>
+              <a:t>FKB Campus  ·  M10</a:t>
+            </a:r>
+          </a:p>
+        </p:txBody>
+      </p:sp>
+    </p:spTree>
+  </p:cSld>
+  <p:clrMapOvr>
+    <a:masterClrMapping/>
+  </p:clrMapOvr>
+</p:sld>
+</file>
+
 <file path=ppt/slides/slide2.xml><?xml version="1.0" encoding="utf-8"?>
 <p:sld xmlns:a="http://schemas.openxmlformats.org/drawingml/2006/main" xmlns:p="http://schemas.openxmlformats.org/presentationml/2006/main" xmlns:r="http://schemas.openxmlformats.org/officeDocument/2006/relationships">
   <p:cSld>
@@ -5926,7 +7402,7 @@
                 </a:solidFill>
                 <a:latin typeface="Arial"/>
               </a:rPr>
-              <a:t>Theorie-Input: Das Vier-Ohren-Modell</a:t>
+              <a:t>Hör auf allen vier Ohren</a:t>
             </a:r>
           </a:p>
         </p:txBody>
@@ -5952,6 +7428,25 @@
             <a:spAutoFit/>
           </a:bodyPr>
           <a:lstStyle/>
+          <a:p>
+            <a:pPr marL="177800" indent="-177800">
+              <a:spcBef>
+                <a:spcPts val="600"/>
+              </a:spcBef>
+              <a:spcAft>
+                <a:spcPts val="200"/>
+              </a:spcAft>
+            </a:pPr>
+            <a:r>
+              <a:rPr sz="1200" i="1">
+                <a:solidFill>
+                  <a:srgbClr val="3D5466"/>
+                </a:solidFill>
+                <a:latin typeface="Arial"/>
+              </a:rPr>
+              <a:t>→  Hinter jeder Sachaussage steckt eine Botschaft – hör auf allen vier Ohren.</a:t>
+            </a:r>
+          </a:p>
           <a:p>
             <a:pPr marL="190500" indent="-190500">
               <a:spcBef>
@@ -5968,7 +7463,26 @@
                 </a:solidFill>
                 <a:latin typeface="Arial"/>
               </a:rPr>
-              <a:t>▸  Jede Aussage Ihres Unternehmerkunden enthält gleichzeitig vier Botschaften:</a:t>
+              <a:t>▸  Der eigentliche Bedarf liegt selten in dem, was der Kunde sagt, sondern in dem, was er meint.</a:t>
+            </a:r>
+          </a:p>
+          <a:p>
+            <a:pPr marL="190500" indent="-190500">
+              <a:spcBef>
+                <a:spcPts val="400"/>
+              </a:spcBef>
+              <a:spcAft>
+                <a:spcPts val="200"/>
+              </a:spcAft>
+            </a:pPr>
+            <a:r>
+              <a:rPr sz="1300">
+                <a:solidFill>
+                  <a:srgbClr val="3D5466"/>
+                </a:solidFill>
+                <a:latin typeface="Arial"/>
+              </a:rPr>
+              <a:t>▸  Wer nur das Sachohr nutzt, verpasst den Beziehungs-, Selbstoffenbarungs- und Appellgehalt.</a:t>
             </a:r>
           </a:p>
         </p:txBody>
@@ -6306,7 +7820,7 @@
                 </a:solidFill>
                 <a:latin typeface="Arial"/>
               </a:rPr>
-              <a:t>Theorie-Input: Das SPIN-Fragenmodell</a:t>
+              <a:t>Das Vier-Ohren-Modell im Kundengespräch</a:t>
             </a:r>
           </a:p>
         </p:txBody>
@@ -6332,6 +7846,25 @@
             <a:spAutoFit/>
           </a:bodyPr>
           <a:lstStyle/>
+          <a:p>
+            <a:pPr marL="177800" indent="-177800">
+              <a:spcBef>
+                <a:spcPts val="600"/>
+              </a:spcBef>
+              <a:spcAft>
+                <a:spcPts val="200"/>
+              </a:spcAft>
+            </a:pPr>
+            <a:r>
+              <a:rPr sz="1200" i="1">
+                <a:solidFill>
+                  <a:srgbClr val="3D5466"/>
+                </a:solidFill>
+                <a:latin typeface="Arial"/>
+              </a:rPr>
+              <a:t>→  Jede Kundenaussage sendet auf vier Kanälen – der Berater entscheidet, auf welchem er antwortet.</a:t>
+            </a:r>
+          </a:p>
           <a:p>
             <a:pPr marL="190500" indent="-190500">
               <a:spcBef>
@@ -6348,7 +7881,26 @@
                 </a:solidFill>
                 <a:latin typeface="Arial"/>
               </a:rPr>
-              <a:t>▸  Rackham  hat nachgewiesen, dass der Unterschied zwischen durchschnittlichen und herausragenden Beratern primär in der Qualität der Fragen liegt – nicht in der Qualität der Produktpräsentation.</a:t>
+              <a:t>▸  Sachinhalt, Selbstoffenbarung, Beziehung, Appell (Schulz von Thun).</a:t>
+            </a:r>
+          </a:p>
+          <a:p>
+            <a:pPr marL="190500" indent="-190500">
+              <a:spcBef>
+                <a:spcPts val="400"/>
+              </a:spcBef>
+              <a:spcAft>
+                <a:spcPts val="200"/>
+              </a:spcAft>
+            </a:pPr>
+            <a:r>
+              <a:rPr sz="1300">
+                <a:solidFill>
+                  <a:srgbClr val="3D5466"/>
+                </a:solidFill>
+                <a:latin typeface="Arial"/>
+              </a:rPr>
+              <a:t>▸  Reklamationen und Einwände sind fast immer Beziehungs- oder Appellbotschaften.</a:t>
             </a:r>
           </a:p>
         </p:txBody>
@@ -6464,7 +8016,7 @@
             <a:avLst/>
           </a:prstGeom>
           <a:solidFill>
-            <a:srgbClr val="FFFFFF"/>
+            <a:srgbClr val="EDEDF3"/>
           </a:solidFill>
           <a:ln>
             <a:noFill/>
@@ -6565,43 +8117,51 @@
                 </a:solidFill>
                 <a:latin typeface="Consolas"/>
               </a:rPr>
-              <a:t>M10  ·  SCHAUBILD</a:t>
-            </a:r>
-          </a:p>
-        </p:txBody>
-      </p:sp>
-      <p:sp>
-        <p:nvSpPr>
-          <p:cNvPr id="5" name="TextBox 4"/>
-          <p:cNvSpPr txBox="1"/>
-          <p:nvPr/>
-        </p:nvSpPr>
-        <p:spPr>
-          <a:xfrm>
-            <a:off x="685800" y="502920"/>
-            <a:ext cx="10817352" cy="594360"/>
-          </a:xfrm>
-          <a:prstGeom prst="rect">
-            <a:avLst/>
-          </a:prstGeom>
-          <a:noFill/>
-        </p:spPr>
-        <p:txBody>
-          <a:bodyPr wrap="square">
-            <a:spAutoFit/>
-          </a:bodyPr>
-          <a:lstStyle/>
-          <a:p>
-            <a:pPr algn="l"/>
-            <a:r>
-              <a:rPr sz="2000" b="1" i="0">
-                <a:solidFill>
-                  <a:srgbClr val="1F2C56"/>
-                </a:solidFill>
-                <a:latin typeface="Arial"/>
-              </a:rPr>
-              <a:t>SPIN-Fragetrichter nach Rackham</a:t>
-            </a:r>
+              <a:t>M10  ·  INHALT</a:t>
+            </a:r>
+          </a:p>
+        </p:txBody>
+      </p:sp>
+      <p:sp>
+        <p:nvSpPr>
+          <p:cNvPr id="5" name="Rectangle 4"/>
+          <p:cNvSpPr/>
+          <p:nvPr/>
+        </p:nvSpPr>
+        <p:spPr>
+          <a:xfrm>
+            <a:off x="0" y="1234440"/>
+            <a:ext cx="12188952" cy="12700"/>
+          </a:xfrm>
+          <a:prstGeom prst="rect">
+            <a:avLst/>
+          </a:prstGeom>
+          <a:solidFill>
+            <a:srgbClr val="D8DFE4"/>
+          </a:solidFill>
+          <a:ln>
+            <a:noFill/>
+          </a:ln>
+        </p:spPr>
+        <p:style>
+          <a:lnRef idx="1">
+            <a:schemeClr val="accent1"/>
+          </a:lnRef>
+          <a:fillRef idx="3">
+            <a:schemeClr val="accent1"/>
+          </a:fillRef>
+          <a:effectRef idx="2">
+            <a:schemeClr val="accent1"/>
+          </a:effectRef>
+          <a:fontRef idx="minor">
+            <a:schemeClr val="lt1"/>
+          </a:fontRef>
+        </p:style>
+        <p:txBody>
+          <a:bodyPr rtlCol="0" anchor="ctr"/>
+          <a:lstStyle/>
+          <a:p>
+            <a:pPr algn="ctr"/>
           </a:p>
         </p:txBody>
       </p:sp>
@@ -6613,8 +8173,8 @@
         </p:nvSpPr>
         <p:spPr>
           <a:xfrm>
-            <a:off x="685800" y="1143000"/>
-            <a:ext cx="10817352" cy="25400"/>
+            <a:off x="685800" y="502920"/>
+            <a:ext cx="36576" cy="658368"/>
           </a:xfrm>
           <a:prstGeom prst="rect">
             <a:avLst/>
@@ -6648,33 +8208,124 @@
           </a:p>
         </p:txBody>
       </p:sp>
-      <p:pic>
-        <p:nvPicPr>
-          <p:cNvPr id="7" name="Picture 6" descr="image.png"/>
-          <p:cNvPicPr>
-            <a:picLocks noChangeAspect="1"/>
-          </p:cNvPicPr>
-          <p:nvPr/>
-        </p:nvPicPr>
-        <p:blipFill>
-          <a:blip r:embed="rId2"/>
-          <a:stretch>
-            <a:fillRect/>
-          </a:stretch>
-        </p:blipFill>
-        <p:spPr>
-          <a:xfrm>
-            <a:off x="2554863" y="1325880"/>
-            <a:ext cx="7079225" cy="4937760"/>
-          </a:xfrm>
-          <a:prstGeom prst="rect">
-            <a:avLst/>
-          </a:prstGeom>
-        </p:spPr>
-      </p:pic>
-      <p:sp>
-        <p:nvSpPr>
-          <p:cNvPr id="8" name="Rectangle 7"/>
+      <p:sp>
+        <p:nvSpPr>
+          <p:cNvPr id="7" name="TextBox 6"/>
+          <p:cNvSpPr txBox="1"/>
+          <p:nvPr/>
+        </p:nvSpPr>
+        <p:spPr>
+          <a:xfrm>
+            <a:off x="813816" y="502920"/>
+            <a:ext cx="10634472" cy="685800"/>
+          </a:xfrm>
+          <a:prstGeom prst="rect">
+            <a:avLst/>
+          </a:prstGeom>
+          <a:noFill/>
+        </p:spPr>
+        <p:txBody>
+          <a:bodyPr wrap="square">
+            <a:spAutoFit/>
+          </a:bodyPr>
+          <a:lstStyle/>
+          <a:p>
+            <a:pPr algn="l"/>
+            <a:r>
+              <a:rPr sz="2400" b="1" i="0">
+                <a:solidFill>
+                  <a:srgbClr val="1F2C56"/>
+                </a:solidFill>
+                <a:latin typeface="Arial"/>
+              </a:rPr>
+              <a:t>Vom sichtbaren zum latenten Bedarf: SPIN</a:t>
+            </a:r>
+          </a:p>
+        </p:txBody>
+      </p:sp>
+      <p:sp>
+        <p:nvSpPr>
+          <p:cNvPr id="8" name="TextBox 7"/>
+          <p:cNvSpPr txBox="1"/>
+          <p:nvPr/>
+        </p:nvSpPr>
+        <p:spPr>
+          <a:xfrm>
+            <a:off x="685800" y="1417320"/>
+            <a:ext cx="10817352" cy="4892040"/>
+          </a:xfrm>
+          <a:prstGeom prst="rect">
+            <a:avLst/>
+          </a:prstGeom>
+          <a:noFill/>
+        </p:spPr>
+        <p:txBody>
+          <a:bodyPr wrap="square" anchor="ctr">
+            <a:spAutoFit/>
+          </a:bodyPr>
+          <a:lstStyle/>
+          <a:p>
+            <a:pPr marL="177800" indent="-177800">
+              <a:spcBef>
+                <a:spcPts val="600"/>
+              </a:spcBef>
+              <a:spcAft>
+                <a:spcPts val="200"/>
+              </a:spcAft>
+            </a:pPr>
+            <a:r>
+              <a:rPr sz="1200" i="1">
+                <a:solidFill>
+                  <a:srgbClr val="3D5466"/>
+                </a:solidFill>
+                <a:latin typeface="Arial"/>
+              </a:rPr>
+              <a:t>→  SPIN führt vom Ist-Stand über den Engpass zur Lösungsbereitschaft – Fragen statt Präsentieren.</a:t>
+            </a:r>
+          </a:p>
+          <a:p>
+            <a:pPr marL="190500" indent="-190500">
+              <a:spcBef>
+                <a:spcPts val="400"/>
+              </a:spcBef>
+              <a:spcAft>
+                <a:spcPts val="200"/>
+              </a:spcAft>
+            </a:pPr>
+            <a:r>
+              <a:rPr sz="1300">
+                <a:solidFill>
+                  <a:srgbClr val="3D5466"/>
+                </a:solidFill>
+                <a:latin typeface="Arial"/>
+              </a:rPr>
+              <a:t>▸  Situation, Problem, Implikation, Nutzen.</a:t>
+            </a:r>
+          </a:p>
+          <a:p>
+            <a:pPr marL="190500" indent="-190500">
+              <a:spcBef>
+                <a:spcPts val="400"/>
+              </a:spcBef>
+              <a:spcAft>
+                <a:spcPts val="200"/>
+              </a:spcAft>
+            </a:pPr>
+            <a:r>
+              <a:rPr sz="1300">
+                <a:solidFill>
+                  <a:srgbClr val="3D5466"/>
+                </a:solidFill>
+                <a:latin typeface="Arial"/>
+              </a:rPr>
+              <a:t>▸  Der Trichter verengt sich von offenen Situationsfragen zu nutzenorientierten Abschlussfragen.</a:t>
+            </a:r>
+          </a:p>
+        </p:txBody>
+      </p:sp>
+      <p:sp>
+        <p:nvSpPr>
+          <p:cNvPr id="9" name="Rectangle 8"/>
           <p:cNvSpPr/>
           <p:nvPr/>
         </p:nvSpPr>
@@ -6717,7 +8368,7 @@
       </p:sp>
       <p:sp>
         <p:nvSpPr>
-          <p:cNvPr id="9" name="TextBox 8"/>
+          <p:cNvPr id="10" name="TextBox 9"/>
           <p:cNvSpPr txBox="1"/>
           <p:nvPr/>
         </p:nvSpPr>
@@ -6746,41 +8397,6 @@
                 <a:latin typeface="Consolas"/>
               </a:rPr>
               <a:t>FKB Campus  ·  M10</a:t>
-            </a:r>
-          </a:p>
-        </p:txBody>
-      </p:sp>
-      <p:sp>
-        <p:nvSpPr>
-          <p:cNvPr id="10" name="TextBox 9"/>
-          <p:cNvSpPr txBox="1"/>
-          <p:nvPr/>
-        </p:nvSpPr>
-        <p:spPr>
-          <a:xfrm>
-            <a:off x="7176211" y="6583680"/>
-            <a:ext cx="4326940" cy="256032"/>
-          </a:xfrm>
-          <a:prstGeom prst="rect">
-            <a:avLst/>
-          </a:prstGeom>
-          <a:noFill/>
-        </p:spPr>
-        <p:txBody>
-          <a:bodyPr wrap="none">
-            <a:spAutoFit/>
-          </a:bodyPr>
-          <a:lstStyle/>
-          <a:p>
-            <a:pPr algn="r"/>
-            <a:r>
-              <a:rPr sz="700">
-                <a:solidFill>
-                  <a:srgbClr val="A0B4D2"/>
-                </a:solidFill>
-                <a:latin typeface="Consolas"/>
-              </a:rPr>
-              <a:t>Schaubild</a:t>
             </a:r>
           </a:p>
         </p:txBody>
@@ -6818,7 +8434,7 @@
             <a:avLst/>
           </a:prstGeom>
           <a:solidFill>
-            <a:srgbClr val="EDEDF3"/>
+            <a:srgbClr val="FFFFFF"/>
           </a:solidFill>
           <a:ln>
             <a:noFill/>
@@ -6919,51 +8535,43 @@
                 </a:solidFill>
                 <a:latin typeface="Consolas"/>
               </a:rPr>
-              <a:t>M10  ·  INHALT</a:t>
-            </a:r>
-          </a:p>
-        </p:txBody>
-      </p:sp>
-      <p:sp>
-        <p:nvSpPr>
-          <p:cNvPr id="5" name="Rectangle 4"/>
-          <p:cNvSpPr/>
-          <p:nvPr/>
-        </p:nvSpPr>
-        <p:spPr>
-          <a:xfrm>
-            <a:off x="0" y="1234440"/>
-            <a:ext cx="12188952" cy="12700"/>
-          </a:xfrm>
-          <a:prstGeom prst="rect">
-            <a:avLst/>
-          </a:prstGeom>
-          <a:solidFill>
-            <a:srgbClr val="D8DFE4"/>
-          </a:solidFill>
-          <a:ln>
-            <a:noFill/>
-          </a:ln>
-        </p:spPr>
-        <p:style>
-          <a:lnRef idx="1">
-            <a:schemeClr val="accent1"/>
-          </a:lnRef>
-          <a:fillRef idx="3">
-            <a:schemeClr val="accent1"/>
-          </a:fillRef>
-          <a:effectRef idx="2">
-            <a:schemeClr val="accent1"/>
-          </a:effectRef>
-          <a:fontRef idx="minor">
-            <a:schemeClr val="lt1"/>
-          </a:fontRef>
-        </p:style>
-        <p:txBody>
-          <a:bodyPr rtlCol="0" anchor="ctr"/>
-          <a:lstStyle/>
-          <a:p>
-            <a:pPr algn="ctr"/>
+              <a:t>M10  ·  SCHAUBILD</a:t>
+            </a:r>
+          </a:p>
+        </p:txBody>
+      </p:sp>
+      <p:sp>
+        <p:nvSpPr>
+          <p:cNvPr id="5" name="TextBox 4"/>
+          <p:cNvSpPr txBox="1"/>
+          <p:nvPr/>
+        </p:nvSpPr>
+        <p:spPr>
+          <a:xfrm>
+            <a:off x="685800" y="502920"/>
+            <a:ext cx="10817352" cy="594360"/>
+          </a:xfrm>
+          <a:prstGeom prst="rect">
+            <a:avLst/>
+          </a:prstGeom>
+          <a:noFill/>
+        </p:spPr>
+        <p:txBody>
+          <a:bodyPr wrap="square">
+            <a:spAutoFit/>
+          </a:bodyPr>
+          <a:lstStyle/>
+          <a:p>
+            <a:pPr algn="l"/>
+            <a:r>
+              <a:rPr sz="2000" b="1" i="0">
+                <a:solidFill>
+                  <a:srgbClr val="1F2C56"/>
+                </a:solidFill>
+                <a:latin typeface="Arial"/>
+              </a:rPr>
+              <a:t>Der SPIN-Fragetrichter nach Rackham</a:t>
+            </a:r>
           </a:p>
         </p:txBody>
       </p:sp>
@@ -6975,8 +8583,8 @@
         </p:nvSpPr>
         <p:spPr>
           <a:xfrm>
-            <a:off x="685800" y="502920"/>
-            <a:ext cx="36576" cy="658368"/>
+            <a:off x="685800" y="1143000"/>
+            <a:ext cx="10817352" cy="25400"/>
           </a:xfrm>
           <a:prstGeom prst="rect">
             <a:avLst/>
@@ -7010,276 +8618,33 @@
           </a:p>
         </p:txBody>
       </p:sp>
-      <p:sp>
-        <p:nvSpPr>
-          <p:cNvPr id="7" name="TextBox 6"/>
-          <p:cNvSpPr txBox="1"/>
-          <p:nvPr/>
-        </p:nvSpPr>
-        <p:spPr>
-          <a:xfrm>
-            <a:off x="813816" y="502920"/>
-            <a:ext cx="10634472" cy="685800"/>
-          </a:xfrm>
-          <a:prstGeom prst="rect">
-            <a:avLst/>
-          </a:prstGeom>
-          <a:noFill/>
-        </p:spPr>
-        <p:txBody>
-          <a:bodyPr wrap="square">
-            <a:spAutoFit/>
-          </a:bodyPr>
-          <a:lstStyle/>
-          <a:p>
-            <a:pPr algn="l"/>
-            <a:r>
-              <a:rPr sz="2400" b="1" i="0">
-                <a:solidFill>
-                  <a:srgbClr val="1F2C56"/>
-                </a:solidFill>
-                <a:latin typeface="Arial"/>
-              </a:rPr>
-              <a:t>Praxiscase: Florian Maurer, Metallbau GmbH &amp; Co. KG</a:t>
-            </a:r>
-          </a:p>
-        </p:txBody>
-      </p:sp>
-      <p:sp>
-        <p:nvSpPr>
-          <p:cNvPr id="8" name="TextBox 7"/>
-          <p:cNvSpPr txBox="1"/>
-          <p:nvPr/>
-        </p:nvSpPr>
-        <p:spPr>
-          <a:xfrm>
-            <a:off x="685800" y="1417320"/>
-            <a:ext cx="10817352" cy="4892040"/>
-          </a:xfrm>
-          <a:prstGeom prst="rect">
-            <a:avLst/>
-          </a:prstGeom>
-          <a:noFill/>
-        </p:spPr>
-        <p:txBody>
-          <a:bodyPr wrap="square">
-            <a:spAutoFit/>
-          </a:bodyPr>
-          <a:lstStyle/>
-          <a:p>
-            <a:pPr>
-              <a:spcBef>
-                <a:spcPts val="1000"/>
-              </a:spcBef>
-              <a:spcAft>
-                <a:spcPts val="200"/>
-              </a:spcAft>
-            </a:pPr>
-            <a:r>
-              <a:rPr sz="800" b="1">
-                <a:solidFill>
-                  <a:srgbClr val="78808C"/>
-                </a:solidFill>
-                <a:latin typeface="Consolas"/>
-              </a:rPr>
-              <a:t>BEKANNTE BEDARFE (SICHTBAR)</a:t>
-            </a:r>
-          </a:p>
-          <a:p>
-            <a:pPr marL="190500" indent="-190500">
-              <a:spcBef>
-                <a:spcPts val="400"/>
-              </a:spcBef>
-              <a:spcAft>
-                <a:spcPts val="200"/>
-              </a:spcAft>
-            </a:pPr>
-            <a:r>
-              <a:rPr sz="1300">
-                <a:solidFill>
-                  <a:srgbClr val="3D5466"/>
-                </a:solidFill>
-                <a:latin typeface="Arial"/>
-              </a:rPr>
-              <a:t>▸  Maschinenerneuerung: Zwei Drehmaschinen (Investitionsvolumen ca. 180 TEUR) geplant</a:t>
-            </a:r>
-          </a:p>
-          <a:p>
-            <a:pPr marL="190500" indent="-190500">
-              <a:spcBef>
-                <a:spcPts val="400"/>
-              </a:spcBef>
-              <a:spcAft>
-                <a:spcPts val="200"/>
-              </a:spcAft>
-            </a:pPr>
-            <a:r>
-              <a:rPr sz="1300">
-                <a:solidFill>
-                  <a:srgbClr val="3D5466"/>
-                </a:solidFill>
-                <a:latin typeface="Arial"/>
-              </a:rPr>
-              <a:t>▸  Erweiterung der Kontokorrentlinie auf 400 TEUR für Auftragsvorfinanzierung</a:t>
-            </a:r>
-          </a:p>
-          <a:p>
-            <a:pPr>
-              <a:spcBef>
-                <a:spcPts val="1000"/>
-              </a:spcBef>
-              <a:spcAft>
-                <a:spcPts val="200"/>
-              </a:spcAft>
-            </a:pPr>
-            <a:r>
-              <a:rPr sz="800" b="1">
-                <a:solidFill>
-                  <a:srgbClr val="78808C"/>
-                </a:solidFill>
-                <a:latin typeface="Consolas"/>
-              </a:rPr>
-              <a:t>LATENTE BEDARFE (NUR DEM UNTERNEHMER BEKANNT – FÜR ROLLENSPIELER)</a:t>
-            </a:r>
-          </a:p>
-          <a:p>
-            <a:pPr marL="190500" indent="-190500">
-              <a:spcBef>
-                <a:spcPts val="400"/>
-              </a:spcBef>
-              <a:spcAft>
-                <a:spcPts val="200"/>
-              </a:spcAft>
-            </a:pPr>
-            <a:r>
-              <a:rPr sz="1300">
-                <a:solidFill>
-                  <a:srgbClr val="3D5466"/>
-                </a:solidFill>
-                <a:latin typeface="Arial"/>
-              </a:rPr>
-              <a:t>▸  Nachfolge ungeklärt (echter latenter Bedarf): Sohn (26) zeigt kein Interesse; Maurer hat kein Testament, keinen Gesellschaftervertrag für den Todesfall. Maurer spricht nicht darüber, weil er das Thema mit sich selbst noch nicht geklärt hat – er hofft, der Sohn ändert noch seine Meinung.</a:t>
-            </a:r>
-          </a:p>
-          <a:p>
-            <a:pPr marL="190500" indent="-190500">
-              <a:spcBef>
-                <a:spcPts val="400"/>
-              </a:spcBef>
-              <a:spcAft>
-                <a:spcPts val="200"/>
-              </a:spcAft>
-            </a:pPr>
-            <a:r>
-              <a:rPr sz="1300">
-                <a:solidFill>
-                  <a:srgbClr val="3D5466"/>
-                </a:solidFill>
-                <a:latin typeface="Arial"/>
-              </a:rPr>
-              <a:t>▸  Stille Beteiligung läuft aus (echter latenter Bedarf): Ein Schwager ist seit 2012 stiller Gesellschafter (80 TEUR). Die Beteiligung hat eine Kündigungsfrist bis Ende 2025; Maurer hat noch keine Anschlussfinanzierung. Er spricht nicht darüber, weil er befürchtet, die Bank könnte das als Risiko werten.</a:t>
-            </a:r>
-          </a:p>
-          <a:p>
-            <a:pPr marL="190500" indent="-190500">
-              <a:spcBef>
-                <a:spcPts val="400"/>
-              </a:spcBef>
-              <a:spcAft>
-                <a:spcPts val="200"/>
-              </a:spcAft>
-            </a:pPr>
-            <a:r>
-              <a:rPr sz="1300">
-                <a:solidFill>
-                  <a:srgbClr val="3D5466"/>
-                </a:solidFill>
-                <a:latin typeface="Arial"/>
-              </a:rPr>
-              <a:t>▸  Liquiditätsengpass (bekannt, aber nicht priorisiert): Der neue Großkunde zahlt mit 60 Tagen Ziel; bei Großaufträgen (&gt; 80 TEUR) entsteht Vorlauffinanzierungsbedarf. Maurer hält das für ein temporäres Problem und hat KK bisher ausreichend gefunden.</a:t>
-            </a:r>
-          </a:p>
-          <a:p>
-            <a:pPr marL="190500" indent="-190500">
-              <a:spcBef>
-                <a:spcPts val="400"/>
-              </a:spcBef>
-              <a:spcAft>
-                <a:spcPts val="200"/>
-              </a:spcAft>
-            </a:pPr>
-            <a:r>
-              <a:rPr sz="1300">
-                <a:solidFill>
-                  <a:srgbClr val="3D5466"/>
-                </a:solidFill>
-                <a:latin typeface="Arial"/>
-              </a:rPr>
-              <a:t>▸  Private Absicherung (latent): Florian Maurer hat seit Jahren keine BU-Versicherung mehr; private Krankenversicherung läuft als Einzelvertrag ohne Unternehmensbezug.</a:t>
-            </a:r>
-          </a:p>
-          <a:p>
-            <a:pPr>
-              <a:spcBef>
-                <a:spcPts val="1000"/>
-              </a:spcBef>
-              <a:spcAft>
-                <a:spcPts val="200"/>
-              </a:spcAft>
-            </a:pPr>
-            <a:r>
-              <a:rPr sz="800" b="1">
-                <a:solidFill>
-                  <a:srgbClr val="78808C"/>
-                </a:solidFill>
-                <a:latin typeface="Consolas"/>
-              </a:rPr>
-              <a:t>OPTIONALE ROLLENSPIELVARIANTEN (FÜR ERFAHRENE GRUPPEN ODER ZWEITE RUNDE)</a:t>
-            </a:r>
-          </a:p>
-          <a:p>
-            <a:pPr marL="190500" indent="-190500">
-              <a:spcBef>
-                <a:spcPts val="400"/>
-              </a:spcBef>
-              <a:spcAft>
-                <a:spcPts val="200"/>
-              </a:spcAft>
-            </a:pPr>
-            <a:r>
-              <a:rPr sz="1300">
-                <a:solidFill>
-                  <a:srgbClr val="3D5466"/>
-                </a:solidFill>
-                <a:latin typeface="Arial"/>
-              </a:rPr>
-              <a:t>▸  Variante A – Der wortkarger Unternehmer</a:t>
-            </a:r>
-          </a:p>
-          <a:p>
-            <a:pPr marL="190500" indent="-190500">
-              <a:spcBef>
-                <a:spcPts val="400"/>
-              </a:spcBef>
-              <a:spcAft>
-                <a:spcPts val="200"/>
-              </a:spcAft>
-            </a:pPr>
-            <a:r>
-              <a:rPr sz="1300">
-                <a:solidFill>
-                  <a:srgbClr val="3D5466"/>
-                </a:solidFill>
-                <a:latin typeface="Arial"/>
-              </a:rPr>
-              <a:t>▸  Variante B – Zwei Gesellschafter am Tisch (GbR-Situation)</a:t>
-            </a:r>
-          </a:p>
-        </p:txBody>
-      </p:sp>
-      <p:sp>
-        <p:nvSpPr>
-          <p:cNvPr id="9" name="Rectangle 8"/>
+      <p:pic>
+        <p:nvPicPr>
+          <p:cNvPr id="7" name="Picture 6" descr="image.png"/>
+          <p:cNvPicPr>
+            <a:picLocks noChangeAspect="1"/>
+          </p:cNvPicPr>
+          <p:nvPr/>
+        </p:nvPicPr>
+        <p:blipFill>
+          <a:blip r:embed="rId2"/>
+          <a:stretch>
+            <a:fillRect/>
+          </a:stretch>
+        </p:blipFill>
+        <p:spPr>
+          <a:xfrm>
+            <a:off x="2554863" y="1325880"/>
+            <a:ext cx="7079225" cy="4937760"/>
+          </a:xfrm>
+          <a:prstGeom prst="rect">
+            <a:avLst/>
+          </a:prstGeom>
+        </p:spPr>
+      </p:pic>
+      <p:sp>
+        <p:nvSpPr>
+          <p:cNvPr id="8" name="Rectangle 7"/>
           <p:cNvSpPr/>
           <p:nvPr/>
         </p:nvSpPr>
@@ -7322,7 +8687,7 @@
       </p:sp>
       <p:sp>
         <p:nvSpPr>
-          <p:cNvPr id="10" name="TextBox 9"/>
+          <p:cNvPr id="9" name="TextBox 8"/>
           <p:cNvSpPr txBox="1"/>
           <p:nvPr/>
         </p:nvSpPr>
@@ -7351,6 +8716,41 @@
                 <a:latin typeface="Consolas"/>
               </a:rPr>
               <a:t>FKB Campus  ·  M10</a:t>
+            </a:r>
+          </a:p>
+        </p:txBody>
+      </p:sp>
+      <p:sp>
+        <p:nvSpPr>
+          <p:cNvPr id="10" name="TextBox 9"/>
+          <p:cNvSpPr txBox="1"/>
+          <p:nvPr/>
+        </p:nvSpPr>
+        <p:spPr>
+          <a:xfrm>
+            <a:off x="7176211" y="6583680"/>
+            <a:ext cx="4326940" cy="256032"/>
+          </a:xfrm>
+          <a:prstGeom prst="rect">
+            <a:avLst/>
+          </a:prstGeom>
+          <a:noFill/>
+        </p:spPr>
+        <p:txBody>
+          <a:bodyPr wrap="none">
+            <a:spAutoFit/>
+          </a:bodyPr>
+          <a:lstStyle/>
+          <a:p>
+            <a:pPr algn="r"/>
+            <a:r>
+              <a:rPr sz="700">
+                <a:solidFill>
+                  <a:srgbClr val="A0B4D2"/>
+                </a:solidFill>
+                <a:latin typeface="Consolas"/>
+              </a:rPr>
+              <a:t>Schaubild</a:t>
             </a:r>
           </a:p>
         </p:txBody>
@@ -7388,7 +8788,7 @@
             <a:avLst/>
           </a:prstGeom>
           <a:solidFill>
-            <a:srgbClr val="EDEDF3"/>
+            <a:srgbClr val="1F2C56"/>
           </a:solidFill>
           <a:ln>
             <a:noFill/>
@@ -7418,57 +8818,14 @@
       </p:sp>
       <p:sp>
         <p:nvSpPr>
-          <p:cNvPr id="3" name="Rectangle 2"/>
-          <p:cNvSpPr/>
-          <p:nvPr/>
-        </p:nvSpPr>
-        <p:spPr>
-          <a:xfrm>
-            <a:off x="0" y="0"/>
-            <a:ext cx="12188952" cy="50292"/>
-          </a:xfrm>
-          <a:prstGeom prst="rect">
-            <a:avLst/>
-          </a:prstGeom>
-          <a:solidFill>
-            <a:srgbClr val="1F2C56"/>
-          </a:solidFill>
-          <a:ln>
-            <a:noFill/>
-          </a:ln>
-        </p:spPr>
-        <p:style>
-          <a:lnRef idx="1">
-            <a:schemeClr val="accent1"/>
-          </a:lnRef>
-          <a:fillRef idx="3">
-            <a:schemeClr val="accent1"/>
-          </a:fillRef>
-          <a:effectRef idx="2">
-            <a:schemeClr val="accent1"/>
-          </a:effectRef>
-          <a:fontRef idx="minor">
-            <a:schemeClr val="lt1"/>
-          </a:fontRef>
-        </p:style>
-        <p:txBody>
-          <a:bodyPr rtlCol="0" anchor="ctr"/>
-          <a:lstStyle/>
-          <a:p>
-            <a:pPr algn="ctr"/>
-          </a:p>
-        </p:txBody>
-      </p:sp>
-      <p:sp>
-        <p:nvSpPr>
-          <p:cNvPr id="4" name="TextBox 3"/>
+          <p:cNvPr id="3" name="TextBox 2"/>
           <p:cNvSpPr txBox="1"/>
           <p:nvPr/>
         </p:nvSpPr>
         <p:spPr>
           <a:xfrm>
-            <a:off x="685800" y="109728"/>
-            <a:ext cx="10817352" cy="228600"/>
+            <a:off x="685800" y="2377440"/>
+            <a:ext cx="10817352" cy="365760"/>
           </a:xfrm>
           <a:prstGeom prst="rect">
             <a:avLst/>
@@ -7483,70 +8840,27 @@
           <a:p>
             <a:pPr algn="l"/>
             <a:r>
-              <a:rPr sz="750">
-                <a:solidFill>
-                  <a:srgbClr val="78808C"/>
+              <a:rPr sz="1200">
+                <a:solidFill>
+                  <a:srgbClr val="D9C089"/>
                 </a:solidFill>
                 <a:latin typeface="Consolas"/>
               </a:rPr>
-              <a:t>M10  ·  INHALT</a:t>
-            </a:r>
-          </a:p>
-        </p:txBody>
-      </p:sp>
-      <p:sp>
-        <p:nvSpPr>
-          <p:cNvPr id="5" name="Rectangle 4"/>
+              <a:t>ROLLENSPIEL</a:t>
+            </a:r>
+          </a:p>
+        </p:txBody>
+      </p:sp>
+      <p:sp>
+        <p:nvSpPr>
+          <p:cNvPr id="4" name="Rectangle 3"/>
           <p:cNvSpPr/>
           <p:nvPr/>
         </p:nvSpPr>
         <p:spPr>
           <a:xfrm>
-            <a:off x="0" y="1234440"/>
-            <a:ext cx="12188952" cy="12700"/>
-          </a:xfrm>
-          <a:prstGeom prst="rect">
-            <a:avLst/>
-          </a:prstGeom>
-          <a:solidFill>
-            <a:srgbClr val="D8DFE4"/>
-          </a:solidFill>
-          <a:ln>
-            <a:noFill/>
-          </a:ln>
-        </p:spPr>
-        <p:style>
-          <a:lnRef idx="1">
-            <a:schemeClr val="accent1"/>
-          </a:lnRef>
-          <a:fillRef idx="3">
-            <a:schemeClr val="accent1"/>
-          </a:fillRef>
-          <a:effectRef idx="2">
-            <a:schemeClr val="accent1"/>
-          </a:effectRef>
-          <a:fontRef idx="minor">
-            <a:schemeClr val="lt1"/>
-          </a:fontRef>
-        </p:style>
-        <p:txBody>
-          <a:bodyPr rtlCol="0" anchor="ctr"/>
-          <a:lstStyle/>
-          <a:p>
-            <a:pPr algn="ctr"/>
-          </a:p>
-        </p:txBody>
-      </p:sp>
-      <p:sp>
-        <p:nvSpPr>
-          <p:cNvPr id="6" name="Rectangle 5"/>
-          <p:cNvSpPr/>
-          <p:nvPr/>
-        </p:nvSpPr>
-        <p:spPr>
-          <a:xfrm>
-            <a:off x="685800" y="502920"/>
-            <a:ext cx="36576" cy="658368"/>
+            <a:off x="685800" y="2788920"/>
+            <a:ext cx="548640" cy="38100"/>
           </a:xfrm>
           <a:prstGeom prst="rect">
             <a:avLst/>
@@ -7582,14 +8896,14 @@
       </p:sp>
       <p:sp>
         <p:nvSpPr>
-          <p:cNvPr id="7" name="TextBox 6"/>
+          <p:cNvPr id="5" name="TextBox 4"/>
           <p:cNvSpPr txBox="1"/>
           <p:nvPr/>
         </p:nvSpPr>
         <p:spPr>
           <a:xfrm>
-            <a:off x="813816" y="502920"/>
-            <a:ext cx="10634472" cy="685800"/>
+            <a:off x="685800" y="3017520"/>
+            <a:ext cx="10817352" cy="1463040"/>
           </a:xfrm>
           <a:prstGeom prst="rect">
             <a:avLst/>
@@ -7604,27 +8918,27 @@
           <a:p>
             <a:pPr algn="l"/>
             <a:r>
-              <a:rPr sz="2400" b="1" i="0">
-                <a:solidFill>
-                  <a:srgbClr val="1F2C56"/>
+              <a:rPr sz="4000" b="1" i="0">
+                <a:solidFill>
+                  <a:srgbClr val="FFFFFF"/>
                 </a:solidFill>
                 <a:latin typeface="Arial"/>
               </a:rPr>
-              <a:t>AB-1: Beobachtungsbogen Rollenspiel (dritter Rollenspieler)</a:t>
-            </a:r>
-          </a:p>
-        </p:txBody>
-      </p:sp>
-      <p:sp>
-        <p:nvSpPr>
-          <p:cNvPr id="8" name="TextBox 7"/>
+              <a:t>Praxiscase Florian Maurer</a:t>
+            </a:r>
+          </a:p>
+        </p:txBody>
+      </p:sp>
+      <p:sp>
+        <p:nvSpPr>
+          <p:cNvPr id="6" name="TextBox 5"/>
           <p:cNvSpPr txBox="1"/>
           <p:nvPr/>
         </p:nvSpPr>
         <p:spPr>
           <a:xfrm>
-            <a:off x="685800" y="1417320"/>
-            <a:ext cx="10817352" cy="4892040"/>
+            <a:off x="685800" y="4480560"/>
+            <a:ext cx="8653881" cy="1280160"/>
           </a:xfrm>
           <a:prstGeom prst="rect">
             <a:avLst/>
@@ -7632,103 +8946,34 @@
           <a:noFill/>
         </p:spPr>
         <p:txBody>
-          <a:bodyPr wrap="square" anchor="ctr">
+          <a:bodyPr wrap="square">
             <a:spAutoFit/>
           </a:bodyPr>
           <a:lstStyle/>
           <a:p>
-            <a:pPr marL="190500" indent="-190500">
-              <a:spcBef>
-                <a:spcPts val="400"/>
-              </a:spcBef>
-              <a:spcAft>
-                <a:spcPts val="200"/>
-              </a:spcAft>
-            </a:pPr>
-            <a:r>
-              <a:rPr sz="1300">
-                <a:solidFill>
-                  <a:srgbClr val="3D5466"/>
+            <a:pPr algn="l"/>
+            <a:r>
+              <a:rPr sz="1600" b="0" i="0">
+                <a:solidFill>
+                  <a:srgbClr val="C8D2E6"/>
                 </a:solidFill>
                 <a:latin typeface="Arial"/>
               </a:rPr>
-              <a:t>▸  Stärken (2–3 konkrete Beobachtungen):</a:t>
-            </a:r>
-          </a:p>
-          <a:p>
-            <a:pPr marL="190500" indent="-190500">
-              <a:spcBef>
-                <a:spcPts val="400"/>
-              </a:spcBef>
-              <a:spcAft>
-                <a:spcPts val="200"/>
-              </a:spcAft>
-            </a:pPr>
-            <a:r>
-              <a:rPr sz="1300">
-                <a:solidFill>
-                  <a:srgbClr val="3D5466"/>
-                </a:solidFill>
-                <a:latin typeface="Arial"/>
-              </a:rPr>
-              <a:t>▸  Entwicklungsfeld (1 konkreter, umsetzbarer Hinweis):</a:t>
-            </a:r>
-          </a:p>
-        </p:txBody>
-      </p:sp>
-      <p:sp>
-        <p:nvSpPr>
-          <p:cNvPr id="9" name="Rectangle 8"/>
-          <p:cNvSpPr/>
-          <p:nvPr/>
-        </p:nvSpPr>
-        <p:spPr>
-          <a:xfrm>
-            <a:off x="0" y="6510528"/>
-            <a:ext cx="12188952" cy="347472"/>
-          </a:xfrm>
-          <a:prstGeom prst="rect">
-            <a:avLst/>
-          </a:prstGeom>
-          <a:solidFill>
-            <a:srgbClr val="0A1937"/>
-          </a:solidFill>
-          <a:ln>
-            <a:noFill/>
-          </a:ln>
-        </p:spPr>
-        <p:style>
-          <a:lnRef idx="1">
-            <a:schemeClr val="accent1"/>
-          </a:lnRef>
-          <a:fillRef idx="3">
-            <a:schemeClr val="accent1"/>
-          </a:fillRef>
-          <a:effectRef idx="2">
-            <a:schemeClr val="accent1"/>
-          </a:effectRef>
-          <a:fontRef idx="minor">
-            <a:schemeClr val="lt1"/>
-          </a:fontRef>
-        </p:style>
-        <p:txBody>
-          <a:bodyPr rtlCol="0" anchor="ctr"/>
-          <a:lstStyle/>
-          <a:p>
-            <a:pPr algn="ctr"/>
-          </a:p>
-        </p:txBody>
-      </p:sp>
-      <p:sp>
-        <p:nvSpPr>
-          <p:cNvPr id="10" name="TextBox 9"/>
+              <a:t>Vier Ohren und SPIN in einem echten Kundengespräch anwenden.</a:t>
+            </a:r>
+          </a:p>
+        </p:txBody>
+      </p:sp>
+      <p:sp>
+        <p:nvSpPr>
+          <p:cNvPr id="7" name="TextBox 6"/>
           <p:cNvSpPr txBox="1"/>
           <p:nvPr/>
         </p:nvSpPr>
         <p:spPr>
           <a:xfrm>
-            <a:off x="685800" y="6583680"/>
-            <a:ext cx="6490411" cy="256032"/>
+            <a:off x="685800" y="6355080"/>
+            <a:ext cx="10817352" cy="274320"/>
           </a:xfrm>
           <a:prstGeom prst="rect">
             <a:avLst/>
@@ -7745,7 +8990,7 @@
             <a:r>
               <a:rPr sz="700">
                 <a:solidFill>
-                  <a:srgbClr val="A0B4D2"/>
+                  <a:srgbClr val="8CA0C3"/>
                 </a:solidFill>
                 <a:latin typeface="Consolas"/>
               </a:rPr>

</xml_diff>